<commit_message>
docs(office): rebuild the TDP proposal, budget and deck from screenshots review
</commit_message>
<xml_diff>
--- a/docs/office/TankGuard_Presentation.pptx
+++ b/docs/office/TankGuard_Presentation.pptx
@@ -18851,7 +18851,7 @@
               <a:defRPr sz="3600" b="1"/>
             </a:pPr>
             <a:r>
-              <a:rPr sz="2000"/>
+              <a:rPr sz="3200"/>
               <a:t>TankGuard</a:t>
             </a:r>
             <a:endParaRPr b="0" i="0" sz="1600" u="none" cap="none" strike="noStrike">
@@ -18865,15 +18865,20 @@
             </a:endParaRPr>
           </a:p>
           <a:p>
+            <a:pPr algn="ctr">
+              <a:spcBef>
+                <a:spcPts val="600"/>
+              </a:spcBef>
+              <a:defRPr sz="1400"/>
+            </a:pPr>
             <a:r>
-              <a:rPr sz="2000"/>
-              <a:t>Self-powered IoT water-tank monitoring, pump control and automated sludge cleaning</a:t>
+              <a:rPr sz="1800"/>
+              <a:t>Self-Powered IoT System for In-Tank Water Quality Monitoring and Automated Sediment-Flush</a:t>
             </a:r>
-          </a:p>
-          <a:p>
+            <a:br/>
             <a:r>
-              <a:rPr sz="2000"/>
-              <a:t>Dr. Vishnu Vasudev</a:t>
+              <a:rPr sz="1800"/>
+              <a:t>Dr. Vishnu Vasudev (SBCE, Dept. of ECE)  |  Industry Collaborator: Nuke Labs  |  Theme: IoT TDP 2026 (11)  |  TRL: 6+</a:t>
             </a:r>
           </a:p>
         </p:txBody>
@@ -18910,79 +18915,6 @@
           <a:chExt cx="0" cy="0"/>
         </a:xfrm>
       </p:grpSpPr>
-      <p:sp>
-        <p:nvSpPr>
-          <p:cNvPr id="136" name="Google Shape;136;g25ace02ada9_0_40"/>
-          <p:cNvSpPr txBox="1"/>
-          <p:nvPr>
-            <p:ph idx="1" type="body"/>
-          </p:nvPr>
-        </p:nvSpPr>
-        <p:spPr>
-          <a:xfrm>
-            <a:off x="979713" y="1253331"/>
-            <a:ext cx="10515600" cy="4351338"/>
-          </a:xfrm>
-          <a:prstGeom prst="rect">
-            <a:avLst/>
-          </a:prstGeom>
-          <a:noFill/>
-          <a:ln>
-            <a:noFill/>
-          </a:ln>
-        </p:spPr>
-        <p:txBody>
-          <a:bodyPr anchorCtr="0" anchor="t" bIns="45700" lIns="91425" spcFirstLastPara="1" rIns="91425" wrap="square" tIns="45700">
-            <a:normAutofit/>
-          </a:bodyPr>
-          <a:lstStyle/>
-          <a:p>
-            <a:pPr indent="0" lvl="0" marL="0" rtl="0" algn="l">
-              <a:lnSpc>
-                <a:spcPct val="90000"/>
-              </a:lnSpc>
-              <a:spcBef>
-                <a:spcPts val="1000"/>
-              </a:spcBef>
-              <a:spcAft>
-                <a:spcPts val="0"/>
-              </a:spcAft>
-              <a:buSzPts val="1800"/>
-              <a:buNone/>
-              <a:defRPr sz="1200"/>
-            </a:pPr>
-            <a:r>
-              <a:rPr sz="1600"/>
-              <a:t>Resources and budget (indicative, excl. GST):</a:t>
-            </a:r>
-            <a:endParaRPr/>
-          </a:p>
-          <a:p>
-            <a:r>
-              <a:rPr sz="1600"/>
-              <a:t>M1 monitor: INR 6,500</a:t>
-            </a:r>
-          </a:p>
-          <a:p>
-            <a:r>
-              <a:rPr sz="1600"/>
-              <a:t>H1 home unit: INR 1,800</a:t>
-            </a:r>
-          </a:p>
-          <a:p>
-            <a:r>
-              <a:rPr sz="1600"/>
-              <a:t>C1 cleaning arm: INR 7,300</a:t>
-            </a:r>
-          </a:p>
-          <a:p>
-            <a:r>
-              <a:rPr sz="1600"/>
-              <a:t>Equipment total: INR 15,600; with contingency, overhead and faculty fee: INR 23,587.</a:t>
-            </a:r>
-          </a:p>
-        </p:txBody>
-      </p:sp>
       <p:graphicFrame>
         <p:nvGraphicFramePr>
           <p:cNvPr id="137" name="Google Shape;137;g25ace02ada9_0_40"/>
@@ -18991,7 +18923,7 @@
         </p:nvGraphicFramePr>
         <p:xfrm>
           <a:off x="849085" y="1975757"/>
-          <a:ext cx="3000000" cy="3000000"/>
+          <a:ext cx="3000000" cy="3017520"/>
         </p:xfrm>
         <a:graphic>
           <a:graphicData uri="http://schemas.openxmlformats.org/drawingml/2006/table">
@@ -19007,34 +18939,15 @@
                 <a:gridCol w="2155375"/>
                 <a:gridCol w="2155375"/>
               </a:tblGrid>
-              <a:tr h="417700">
+              <a:tr h="502920">
                 <a:tc>
                   <a:txBody>
                     <a:bodyPr/>
                     <a:lstStyle/>
                     <a:p>
-                      <a:pPr indent="0" lvl="0" marL="0" marR="0" rtl="0" algn="l">
-                        <a:lnSpc>
-                          <a:spcPct val="100000"/>
-                        </a:lnSpc>
-                        <a:spcBef>
-                          <a:spcPts val="0"/>
-                        </a:spcBef>
-                        <a:spcAft>
-                          <a:spcPts val="0"/>
-                        </a:spcAft>
-                        <a:buClr>
-                          <a:srgbClr val="000000"/>
-                        </a:buClr>
-                        <a:buSzPts val="1400"/>
-                        <a:buFont typeface="Arial"/>
-                        <a:buNone/>
-                      </a:pPr>
                       <a:r>
-                        <a:rPr lang="en-US" sz="1400" u="none" cap="none" strike="noStrike"/>
-                        <a:t>Sr. No</a:t>
+                        <a:t>No.</a:t>
                       </a:r>
-                      <a:endParaRPr sz="1400" u="none" cap="none" strike="noStrike"/>
                     </a:p>
                   </a:txBody>
                   <a:tcPr marT="45725" marB="45725" marR="91450" marL="91450"/>
@@ -19044,28 +18957,9 @@
                     <a:bodyPr/>
                     <a:lstStyle/>
                     <a:p>
-                      <a:pPr indent="0" lvl="0" marL="0" marR="0" rtl="0" algn="l">
-                        <a:lnSpc>
-                          <a:spcPct val="100000"/>
-                        </a:lnSpc>
-                        <a:spcBef>
-                          <a:spcPts val="0"/>
-                        </a:spcBef>
-                        <a:spcAft>
-                          <a:spcPts val="0"/>
-                        </a:spcAft>
-                        <a:buClr>
-                          <a:srgbClr val="000000"/>
-                        </a:buClr>
-                        <a:buSzPts val="1400"/>
-                        <a:buFont typeface="Arial"/>
-                        <a:buNone/>
-                      </a:pPr>
                       <a:r>
-                        <a:rPr lang="en-US" sz="1400" u="none" cap="none" strike="noStrike"/>
                         <a:t>Item</a:t>
                       </a:r>
-                      <a:endParaRPr sz="1400" u="none" cap="none" strike="noStrike"/>
                     </a:p>
                   </a:txBody>
                   <a:tcPr marT="45725" marB="45725" marR="91450" marL="91450"/>
@@ -19075,28 +18969,9 @@
                     <a:bodyPr/>
                     <a:lstStyle/>
                     <a:p>
-                      <a:pPr indent="0" lvl="0" marL="0" marR="0" rtl="0" algn="l">
-                        <a:lnSpc>
-                          <a:spcPct val="100000"/>
-                        </a:lnSpc>
-                        <a:spcBef>
-                          <a:spcPts val="0"/>
-                        </a:spcBef>
-                        <a:spcAft>
-                          <a:spcPts val="0"/>
-                        </a:spcAft>
-                        <a:buClr>
-                          <a:srgbClr val="000000"/>
-                        </a:buClr>
-                        <a:buSzPts val="1400"/>
-                        <a:buFont typeface="Arial"/>
-                        <a:buNone/>
-                      </a:pPr>
                       <a:r>
-                        <a:rPr lang="en-US"/>
-                        <a:t>T0</a:t>
+                        <a:t>Specification</a:t>
                       </a:r>
-                      <a:endParaRPr sz="1400" u="none" cap="none" strike="noStrike"/>
                     </a:p>
                   </a:txBody>
                   <a:tcPr marT="45725" marB="45725" marR="91450" marL="91450"/>
@@ -19106,28 +18981,9 @@
                     <a:bodyPr/>
                     <a:lstStyle/>
                     <a:p>
-                      <a:pPr indent="0" lvl="0" marL="0" marR="0" rtl="0" algn="l">
-                        <a:lnSpc>
-                          <a:spcPct val="100000"/>
-                        </a:lnSpc>
-                        <a:spcBef>
-                          <a:spcPts val="0"/>
-                        </a:spcBef>
-                        <a:spcAft>
-                          <a:spcPts val="0"/>
-                        </a:spcAft>
-                        <a:buClr>
-                          <a:srgbClr val="000000"/>
-                        </a:buClr>
-                        <a:buSzPts val="1400"/>
-                        <a:buFont typeface="Arial"/>
-                        <a:buNone/>
-                      </a:pPr>
                       <a:r>
-                        <a:rPr lang="en-US"/>
-                        <a:t>T0+6 </a:t>
+                        <a:t>Amount (INR)</a:t>
                       </a:r>
-                      <a:endParaRPr sz="1400" u="none" cap="none" strike="noStrike"/>
                     </a:p>
                   </a:txBody>
                   <a:tcPr marT="45725" marB="45725" marR="91450" marL="91450"/>
@@ -19137,64 +18993,23 @@
                     <a:bodyPr/>
                     <a:lstStyle/>
                     <a:p>
-                      <a:pPr indent="0" lvl="0" marL="0" marR="0" rtl="0" algn="l">
-                        <a:lnSpc>
-                          <a:spcPct val="100000"/>
-                        </a:lnSpc>
-                        <a:spcBef>
-                          <a:spcPts val="0"/>
-                        </a:spcBef>
-                        <a:spcAft>
-                          <a:spcPts val="0"/>
-                        </a:spcAft>
-                        <a:buClr>
-                          <a:srgbClr val="000000"/>
-                        </a:buClr>
-                        <a:buSzPts val="1400"/>
-                        <a:buFont typeface="Arial"/>
-                        <a:buNone/>
-                      </a:pPr>
                       <a:r>
-                        <a:rPr lang="en-US" sz="1400" u="none" cap="none" strike="noStrike"/>
-                        <a:t>Total (Add more columns if requir</a:t>
+                        <a:t>Phase</a:t>
                       </a:r>
-                      <a:r>
-                        <a:rPr lang="en-US"/>
-                        <a:t>ed)</a:t>
-                      </a:r>
-                      <a:endParaRPr sz="1400" u="none" cap="none" strike="noStrike"/>
                     </a:p>
                   </a:txBody>
                   <a:tcPr marT="45725" marB="45725" marR="91450" marL="91450"/>
                 </a:tc>
               </a:tr>
-              <a:tr h="558600">
+              <a:tr h="502920">
                 <a:tc>
                   <a:txBody>
                     <a:bodyPr/>
                     <a:lstStyle/>
                     <a:p>
-                      <a:pPr indent="0" lvl="0" marL="0" marR="0" rtl="0" algn="l">
-                        <a:lnSpc>
-                          <a:spcPct val="100000"/>
-                        </a:lnSpc>
-                        <a:spcBef>
-                          <a:spcPts val="0"/>
-                        </a:spcBef>
-                        <a:spcAft>
-                          <a:spcPts val="0"/>
-                        </a:spcAft>
-                        <a:buClr>
-                          <a:srgbClr val="000000"/>
-                        </a:buClr>
-                        <a:buSzPts val="1400"/>
-                        <a:buFont typeface="Arial"/>
-                        <a:buNone/>
-                      </a:pPr>
                       <a:r>
-                        <a:t/>
+                        <a:t>1</a:t>
                       </a:r>
-                      <a:endParaRPr sz="1400" u="none" cap="none" strike="noStrike"/>
                     </a:p>
                   </a:txBody>
                   <a:tcPr marT="45725" marB="45725" marR="91450" marL="91450"/>
@@ -19204,27 +19019,9 @@
                     <a:bodyPr/>
                     <a:lstStyle/>
                     <a:p>
-                      <a:pPr indent="0" lvl="0" marL="0" marR="0" rtl="0" algn="l">
-                        <a:lnSpc>
-                          <a:spcPct val="100000"/>
-                        </a:lnSpc>
-                        <a:spcBef>
-                          <a:spcPts val="0"/>
-                        </a:spcBef>
-                        <a:spcAft>
-                          <a:spcPts val="0"/>
-                        </a:spcAft>
-                        <a:buClr>
-                          <a:srgbClr val="000000"/>
-                        </a:buClr>
-                        <a:buSzPts val="1400"/>
-                        <a:buFont typeface="Arial"/>
-                        <a:buNone/>
-                      </a:pPr>
                       <a:r>
-                        <a:t/>
+                        <a:t>M1 monitor</a:t>
                       </a:r>
-                      <a:endParaRPr sz="1400" u="none" cap="none" strike="noStrike"/>
                     </a:p>
                   </a:txBody>
                   <a:tcPr marT="45725" marB="45725" marR="91450" marL="91450"/>
@@ -19234,27 +19031,9 @@
                     <a:bodyPr/>
                     <a:lstStyle/>
                     <a:p>
-                      <a:pPr indent="0" lvl="0" marL="0" marR="0" rtl="0" algn="l">
-                        <a:lnSpc>
-                          <a:spcPct val="100000"/>
-                        </a:lnSpc>
-                        <a:spcBef>
-                          <a:spcPts val="0"/>
-                        </a:spcBef>
-                        <a:spcAft>
-                          <a:spcPts val="0"/>
-                        </a:spcAft>
-                        <a:buClr>
-                          <a:srgbClr val="000000"/>
-                        </a:buClr>
-                        <a:buSzPts val="1400"/>
-                        <a:buFont typeface="Arial"/>
-                        <a:buNone/>
-                      </a:pPr>
                       <a:r>
-                        <a:t/>
+                        <a:t>ESP8266 + 5 probes</a:t>
                       </a:r>
-                      <a:endParaRPr sz="1400" u="none" cap="none" strike="noStrike"/>
                     </a:p>
                   </a:txBody>
                   <a:tcPr marT="45725" marB="45725" marR="91450" marL="91450"/>
@@ -19264,27 +19043,9 @@
                     <a:bodyPr/>
                     <a:lstStyle/>
                     <a:p>
-                      <a:pPr indent="0" lvl="0" marL="0" marR="0" rtl="0" algn="l">
-                        <a:lnSpc>
-                          <a:spcPct val="100000"/>
-                        </a:lnSpc>
-                        <a:spcBef>
-                          <a:spcPts val="0"/>
-                        </a:spcBef>
-                        <a:spcAft>
-                          <a:spcPts val="0"/>
-                        </a:spcAft>
-                        <a:buClr>
-                          <a:srgbClr val="000000"/>
-                        </a:buClr>
-                        <a:buSzPts val="1400"/>
-                        <a:buFont typeface="Arial"/>
-                        <a:buNone/>
-                      </a:pPr>
                       <a:r>
-                        <a:t/>
+                        <a:t>6,500</a:t>
                       </a:r>
-                      <a:endParaRPr sz="1400" u="none" cap="none" strike="noStrike"/>
                     </a:p>
                   </a:txBody>
                   <a:tcPr marT="45725" marB="45725" marR="91450" marL="91450"/>
@@ -19294,59 +19055,23 @@
                     <a:bodyPr/>
                     <a:lstStyle/>
                     <a:p>
-                      <a:pPr indent="0" lvl="0" marL="0" marR="0" rtl="0" algn="l">
-                        <a:lnSpc>
-                          <a:spcPct val="100000"/>
-                        </a:lnSpc>
-                        <a:spcBef>
-                          <a:spcPts val="0"/>
-                        </a:spcBef>
-                        <a:spcAft>
-                          <a:spcPts val="0"/>
-                        </a:spcAft>
-                        <a:buClr>
-                          <a:srgbClr val="000000"/>
-                        </a:buClr>
-                        <a:buSzPts val="1400"/>
-                        <a:buFont typeface="Arial"/>
-                        <a:buNone/>
-                      </a:pPr>
                       <a:r>
-                        <a:t/>
+                        <a:t>T0</a:t>
                       </a:r>
-                      <a:endParaRPr sz="1400" u="none" cap="none" strike="noStrike"/>
                     </a:p>
                   </a:txBody>
                   <a:tcPr marT="45725" marB="45725" marR="91450" marL="91450"/>
                 </a:tc>
               </a:tr>
-              <a:tr h="558600">
+              <a:tr h="502920">
                 <a:tc>
                   <a:txBody>
                     <a:bodyPr/>
                     <a:lstStyle/>
                     <a:p>
-                      <a:pPr indent="0" lvl="0" marL="0" marR="0" rtl="0" algn="l">
-                        <a:lnSpc>
-                          <a:spcPct val="100000"/>
-                        </a:lnSpc>
-                        <a:spcBef>
-                          <a:spcPts val="0"/>
-                        </a:spcBef>
-                        <a:spcAft>
-                          <a:spcPts val="0"/>
-                        </a:spcAft>
-                        <a:buClr>
-                          <a:srgbClr val="000000"/>
-                        </a:buClr>
-                        <a:buSzPts val="1400"/>
-                        <a:buFont typeface="Arial"/>
-                        <a:buNone/>
-                      </a:pPr>
                       <a:r>
-                        <a:t/>
+                        <a:t>2</a:t>
                       </a:r>
-                      <a:endParaRPr sz="1400" u="none" cap="none" strike="noStrike"/>
                     </a:p>
                   </a:txBody>
                   <a:tcPr marT="45725" marB="45725" marR="91450" marL="91450"/>
@@ -19356,27 +19081,9 @@
                     <a:bodyPr/>
                     <a:lstStyle/>
                     <a:p>
-                      <a:pPr indent="0" lvl="0" marL="0" marR="0" rtl="0" algn="l">
-                        <a:lnSpc>
-                          <a:spcPct val="100000"/>
-                        </a:lnSpc>
-                        <a:spcBef>
-                          <a:spcPts val="0"/>
-                        </a:spcBef>
-                        <a:spcAft>
-                          <a:spcPts val="0"/>
-                        </a:spcAft>
-                        <a:buClr>
-                          <a:srgbClr val="000000"/>
-                        </a:buClr>
-                        <a:buSzPts val="1400"/>
-                        <a:buFont typeface="Arial"/>
-                        <a:buNone/>
-                      </a:pPr>
                       <a:r>
-                        <a:t/>
+                        <a:t>H1 home unit</a:t>
                       </a:r>
-                      <a:endParaRPr sz="1400" u="none" cap="none" strike="noStrike"/>
                     </a:p>
                   </a:txBody>
                   <a:tcPr marT="45725" marB="45725" marR="91450" marL="91450"/>
@@ -19386,27 +19093,9 @@
                     <a:bodyPr/>
                     <a:lstStyle/>
                     <a:p>
-                      <a:pPr indent="0" lvl="0" marL="0" marR="0" rtl="0" algn="l">
-                        <a:lnSpc>
-                          <a:spcPct val="100000"/>
-                        </a:lnSpc>
-                        <a:spcBef>
-                          <a:spcPts val="0"/>
-                        </a:spcBef>
-                        <a:spcAft>
-                          <a:spcPts val="0"/>
-                        </a:spcAft>
-                        <a:buClr>
-                          <a:srgbClr val="000000"/>
-                        </a:buClr>
-                        <a:buSzPts val="1400"/>
-                        <a:buFont typeface="Arial"/>
-                        <a:buNone/>
-                      </a:pPr>
                       <a:r>
-                        <a:t/>
+                        <a:t>ESP8266 + TFT + relay</a:t>
                       </a:r>
-                      <a:endParaRPr sz="1400" u="none" cap="none" strike="noStrike"/>
                     </a:p>
                   </a:txBody>
                   <a:tcPr marT="45725" marB="45725" marR="91450" marL="91450"/>
@@ -19416,27 +19105,9 @@
                     <a:bodyPr/>
                     <a:lstStyle/>
                     <a:p>
-                      <a:pPr indent="0" lvl="0" marL="0" marR="0" rtl="0" algn="l">
-                        <a:lnSpc>
-                          <a:spcPct val="100000"/>
-                        </a:lnSpc>
-                        <a:spcBef>
-                          <a:spcPts val="0"/>
-                        </a:spcBef>
-                        <a:spcAft>
-                          <a:spcPts val="0"/>
-                        </a:spcAft>
-                        <a:buClr>
-                          <a:srgbClr val="000000"/>
-                        </a:buClr>
-                        <a:buSzPts val="1400"/>
-                        <a:buFont typeface="Arial"/>
-                        <a:buNone/>
-                      </a:pPr>
                       <a:r>
-                        <a:t/>
+                        <a:t>1,800</a:t>
                       </a:r>
-                      <a:endParaRPr sz="1400" u="none" cap="none" strike="noStrike"/>
                     </a:p>
                   </a:txBody>
                   <a:tcPr marT="45725" marB="45725" marR="91450" marL="91450"/>
@@ -19446,59 +19117,23 @@
                     <a:bodyPr/>
                     <a:lstStyle/>
                     <a:p>
-                      <a:pPr indent="0" lvl="0" marL="0" marR="0" rtl="0" algn="l">
-                        <a:lnSpc>
-                          <a:spcPct val="100000"/>
-                        </a:lnSpc>
-                        <a:spcBef>
-                          <a:spcPts val="0"/>
-                        </a:spcBef>
-                        <a:spcAft>
-                          <a:spcPts val="0"/>
-                        </a:spcAft>
-                        <a:buClr>
-                          <a:srgbClr val="000000"/>
-                        </a:buClr>
-                        <a:buSzPts val="1400"/>
-                        <a:buFont typeface="Arial"/>
-                        <a:buNone/>
-                      </a:pPr>
                       <a:r>
-                        <a:t/>
+                        <a:t>T0 + 4</a:t>
                       </a:r>
-                      <a:endParaRPr sz="1400" u="none" cap="none" strike="noStrike"/>
                     </a:p>
                   </a:txBody>
                   <a:tcPr marT="45725" marB="45725" marR="91450" marL="91450"/>
                 </a:tc>
               </a:tr>
-              <a:tr h="558600">
+              <a:tr h="502920">
                 <a:tc>
                   <a:txBody>
                     <a:bodyPr/>
                     <a:lstStyle/>
                     <a:p>
-                      <a:pPr indent="0" lvl="0" marL="0" marR="0" rtl="0" algn="l">
-                        <a:lnSpc>
-                          <a:spcPct val="100000"/>
-                        </a:lnSpc>
-                        <a:spcBef>
-                          <a:spcPts val="0"/>
-                        </a:spcBef>
-                        <a:spcAft>
-                          <a:spcPts val="0"/>
-                        </a:spcAft>
-                        <a:buClr>
-                          <a:srgbClr val="000000"/>
-                        </a:buClr>
-                        <a:buSzPts val="1400"/>
-                        <a:buFont typeface="Arial"/>
-                        <a:buNone/>
-                      </a:pPr>
                       <a:r>
-                        <a:t/>
+                        <a:t>3</a:t>
                       </a:r>
-                      <a:endParaRPr sz="1400" u="none" cap="none" strike="noStrike"/>
                     </a:p>
                   </a:txBody>
                   <a:tcPr marT="45725" marB="45725" marR="91450" marL="91450"/>
@@ -19508,27 +19143,9 @@
                     <a:bodyPr/>
                     <a:lstStyle/>
                     <a:p>
-                      <a:pPr indent="0" lvl="0" marL="0" marR="0" rtl="0" algn="l">
-                        <a:lnSpc>
-                          <a:spcPct val="100000"/>
-                        </a:lnSpc>
-                        <a:spcBef>
-                          <a:spcPts val="0"/>
-                        </a:spcBef>
-                        <a:spcAft>
-                          <a:spcPts val="0"/>
-                        </a:spcAft>
-                        <a:buClr>
-                          <a:srgbClr val="000000"/>
-                        </a:buClr>
-                        <a:buSzPts val="1400"/>
-                        <a:buFont typeface="Arial"/>
-                        <a:buNone/>
-                      </a:pPr>
                       <a:r>
-                        <a:t/>
+                        <a:t>C1 cleaning arm</a:t>
                       </a:r>
-                      <a:endParaRPr sz="1400" u="none" cap="none" strike="noStrike"/>
                     </a:p>
                   </a:txBody>
                   <a:tcPr marT="45725" marB="45725" marR="91450" marL="91450"/>
@@ -19538,27 +19155,9 @@
                     <a:bodyPr/>
                     <a:lstStyle/>
                     <a:p>
-                      <a:pPr indent="0" lvl="0" marL="0" marR="0" rtl="0" algn="l">
-                        <a:lnSpc>
-                          <a:spcPct val="100000"/>
-                        </a:lnSpc>
-                        <a:spcBef>
-                          <a:spcPts val="0"/>
-                        </a:spcBef>
-                        <a:spcAft>
-                          <a:spcPts val="0"/>
-                        </a:spcAft>
-                        <a:buClr>
-                          <a:srgbClr val="000000"/>
-                        </a:buClr>
-                        <a:buSzPts val="1400"/>
-                        <a:buFont typeface="Arial"/>
-                        <a:buNone/>
-                      </a:pPr>
                       <a:r>
-                        <a:t/>
+                        <a:t>ESP32 + 2 motors + pump</a:t>
                       </a:r>
-                      <a:endParaRPr sz="1400" u="none" cap="none" strike="noStrike"/>
                     </a:p>
                   </a:txBody>
                   <a:tcPr marT="45725" marB="45725" marR="91450" marL="91450"/>
@@ -19568,27 +19167,9 @@
                     <a:bodyPr/>
                     <a:lstStyle/>
                     <a:p>
-                      <a:pPr indent="0" lvl="0" marL="0" marR="0" rtl="0" algn="l">
-                        <a:lnSpc>
-                          <a:spcPct val="100000"/>
-                        </a:lnSpc>
-                        <a:spcBef>
-                          <a:spcPts val="0"/>
-                        </a:spcBef>
-                        <a:spcAft>
-                          <a:spcPts val="0"/>
-                        </a:spcAft>
-                        <a:buClr>
-                          <a:srgbClr val="000000"/>
-                        </a:buClr>
-                        <a:buSzPts val="1400"/>
-                        <a:buFont typeface="Arial"/>
-                        <a:buNone/>
-                      </a:pPr>
                       <a:r>
-                        <a:t/>
+                        <a:t>7,300</a:t>
                       </a:r>
-                      <a:endParaRPr sz="1400" u="none" cap="none" strike="noStrike"/>
                     </a:p>
                   </a:txBody>
                   <a:tcPr marT="45725" marB="45725" marR="91450" marL="91450"/>
@@ -19598,59 +19179,81 @@
                     <a:bodyPr/>
                     <a:lstStyle/>
                     <a:p>
-                      <a:pPr indent="0" lvl="0" marL="0" marR="0" rtl="0" algn="l">
-                        <a:lnSpc>
-                          <a:spcPct val="100000"/>
-                        </a:lnSpc>
-                        <a:spcBef>
-                          <a:spcPts val="0"/>
-                        </a:spcBef>
-                        <a:spcAft>
-                          <a:spcPts val="0"/>
-                        </a:spcAft>
-                        <a:buClr>
-                          <a:srgbClr val="000000"/>
-                        </a:buClr>
-                        <a:buSzPts val="1400"/>
-                        <a:buFont typeface="Arial"/>
-                        <a:buNone/>
-                      </a:pPr>
                       <a:r>
-                        <a:t/>
+                        <a:t>T0 + 8</a:t>
                       </a:r>
-                      <a:endParaRPr sz="1400" u="none" cap="none" strike="noStrike"/>
                     </a:p>
                   </a:txBody>
                   <a:tcPr marT="45725" marB="45725" marR="91450" marL="91450"/>
                 </a:tc>
               </a:tr>
-              <a:tr h="558600">
+              <a:tr h="502920">
+                <a:tc>
+                  <a:txBody>
+                    <a:bodyPr/>
+                    <a:lstStyle/>
+                    <a:p/>
+                  </a:txBody>
+                  <a:tcPr marT="45725" marB="45725" marR="91450" marL="91450"/>
+                </a:tc>
                 <a:tc>
                   <a:txBody>
                     <a:bodyPr/>
                     <a:lstStyle/>
                     <a:p>
-                      <a:pPr indent="0" lvl="0" marL="0" marR="0" rtl="0" algn="l">
-                        <a:lnSpc>
-                          <a:spcPct val="100000"/>
-                        </a:lnSpc>
-                        <a:spcBef>
-                          <a:spcPts val="0"/>
-                        </a:spcBef>
-                        <a:spcAft>
-                          <a:spcPts val="0"/>
-                        </a:spcAft>
-                        <a:buClr>
-                          <a:srgbClr val="000000"/>
-                        </a:buClr>
-                        <a:buSzPts val="1400"/>
-                        <a:buFont typeface="Arial"/>
-                        <a:buNone/>
-                      </a:pPr>
                       <a:r>
-                        <a:t/>
+                        <a:t>Equipment total</a:t>
                       </a:r>
-                      <a:endParaRPr sz="1400" u="none" cap="none" strike="noStrike"/>
+                    </a:p>
+                  </a:txBody>
+                  <a:tcPr marT="45725" marB="45725" marR="91450" marL="91450"/>
+                </a:tc>
+                <a:tc>
+                  <a:txBody>
+                    <a:bodyPr/>
+                    <a:lstStyle/>
+                    <a:p/>
+                  </a:txBody>
+                  <a:tcPr marT="45725" marB="45725" marR="91450" marL="91450"/>
+                </a:tc>
+                <a:tc>
+                  <a:txBody>
+                    <a:bodyPr/>
+                    <a:lstStyle/>
+                    <a:p>
+                      <a:r>
+                        <a:t>15,600</a:t>
+                      </a:r>
+                    </a:p>
+                  </a:txBody>
+                  <a:tcPr marT="45725" marB="45725" marR="91450" marL="91450"/>
+                </a:tc>
+                <a:tc>
+                  <a:txBody>
+                    <a:bodyPr/>
+                    <a:lstStyle/>
+                    <a:p/>
+                  </a:txBody>
+                  <a:tcPr marT="45725" marB="45725" marR="91450" marL="91450"/>
+                </a:tc>
+              </a:tr>
+              <a:tr h="502920">
+                <a:tc>
+                  <a:txBody>
+                    <a:bodyPr/>
+                    <a:lstStyle/>
+                    <a:p/>
+                  </a:txBody>
+                  <a:tcPr marT="45725" marB="45725" marR="91450" marL="91450"/>
+                </a:tc>
+                <a:tc>
+                  <a:txBody>
+                    <a:bodyPr/>
+                    <a:lstStyle/>
+                    <a:p>
+                      <a:r>
+                        <a:t>Grand total</a:t>
+                      </a:r>
                     </a:p>
                   </a:txBody>
                   <a:tcPr marT="45725" marB="45725" marR="91450" marL="91450"/>
@@ -19660,27 +19263,9 @@
                     <a:bodyPr/>
                     <a:lstStyle/>
                     <a:p>
-                      <a:pPr indent="0" lvl="0" marL="0" marR="0" rtl="0" algn="l">
-                        <a:lnSpc>
-                          <a:spcPct val="100000"/>
-                        </a:lnSpc>
-                        <a:spcBef>
-                          <a:spcPts val="0"/>
-                        </a:spcBef>
-                        <a:spcAft>
-                          <a:spcPts val="0"/>
-                        </a:spcAft>
-                        <a:buClr>
-                          <a:srgbClr val="000000"/>
-                        </a:buClr>
-                        <a:buSzPts val="1400"/>
-                        <a:buFont typeface="Arial"/>
-                        <a:buNone/>
-                      </a:pPr>
                       <a:r>
-                        <a:t/>
+                        <a:t>incl. contingency, overhead, fee</a:t>
                       </a:r>
-                      <a:endParaRPr sz="1400" u="none" cap="none" strike="noStrike"/>
                     </a:p>
                   </a:txBody>
                   <a:tcPr marT="45725" marB="45725" marR="91450" marL="91450"/>
@@ -19690,27 +19275,9 @@
                     <a:bodyPr/>
                     <a:lstStyle/>
                     <a:p>
-                      <a:pPr indent="0" lvl="0" marL="0" marR="0" rtl="0" algn="l">
-                        <a:lnSpc>
-                          <a:spcPct val="100000"/>
-                        </a:lnSpc>
-                        <a:spcBef>
-                          <a:spcPts val="0"/>
-                        </a:spcBef>
-                        <a:spcAft>
-                          <a:spcPts val="0"/>
-                        </a:spcAft>
-                        <a:buClr>
-                          <a:srgbClr val="000000"/>
-                        </a:buClr>
-                        <a:buSzPts val="1400"/>
-                        <a:buFont typeface="Arial"/>
-                        <a:buNone/>
-                      </a:pPr>
                       <a:r>
-                        <a:t/>
+                        <a:t>23,587</a:t>
                       </a:r>
-                      <a:endParaRPr sz="1400" u="none" cap="none" strike="noStrike"/>
                     </a:p>
                   </a:txBody>
                   <a:tcPr marT="45725" marB="45725" marR="91450" marL="91450"/>
@@ -19719,211 +19286,7 @@
                   <a:txBody>
                     <a:bodyPr/>
                     <a:lstStyle/>
-                    <a:p>
-                      <a:pPr indent="0" lvl="0" marL="0" marR="0" rtl="0" algn="l">
-                        <a:lnSpc>
-                          <a:spcPct val="100000"/>
-                        </a:lnSpc>
-                        <a:spcBef>
-                          <a:spcPts val="0"/>
-                        </a:spcBef>
-                        <a:spcAft>
-                          <a:spcPts val="0"/>
-                        </a:spcAft>
-                        <a:buClr>
-                          <a:srgbClr val="000000"/>
-                        </a:buClr>
-                        <a:buSzPts val="1400"/>
-                        <a:buFont typeface="Arial"/>
-                        <a:buNone/>
-                      </a:pPr>
-                      <a:r>
-                        <a:t/>
-                      </a:r>
-                      <a:endParaRPr sz="1400" u="none" cap="none" strike="noStrike"/>
-                    </a:p>
-                  </a:txBody>
-                  <a:tcPr marT="45725" marB="45725" marR="91450" marL="91450"/>
-                </a:tc>
-                <a:tc>
-                  <a:txBody>
-                    <a:bodyPr/>
-                    <a:lstStyle/>
-                    <a:p>
-                      <a:pPr indent="0" lvl="0" marL="0" marR="0" rtl="0" algn="l">
-                        <a:lnSpc>
-                          <a:spcPct val="100000"/>
-                        </a:lnSpc>
-                        <a:spcBef>
-                          <a:spcPts val="0"/>
-                        </a:spcBef>
-                        <a:spcAft>
-                          <a:spcPts val="0"/>
-                        </a:spcAft>
-                        <a:buClr>
-                          <a:srgbClr val="000000"/>
-                        </a:buClr>
-                        <a:buSzPts val="1400"/>
-                        <a:buFont typeface="Arial"/>
-                        <a:buNone/>
-                      </a:pPr>
-                      <a:r>
-                        <a:t/>
-                      </a:r>
-                      <a:endParaRPr sz="1400" u="none" cap="none" strike="noStrike"/>
-                    </a:p>
-                  </a:txBody>
-                  <a:tcPr marT="45725" marB="45725" marR="91450" marL="91450"/>
-                </a:tc>
-              </a:tr>
-              <a:tr h="558600">
-                <a:tc>
-                  <a:txBody>
-                    <a:bodyPr/>
-                    <a:lstStyle/>
-                    <a:p>
-                      <a:pPr indent="0" lvl="0" marL="0" marR="0" rtl="0" algn="l">
-                        <a:lnSpc>
-                          <a:spcPct val="100000"/>
-                        </a:lnSpc>
-                        <a:spcBef>
-                          <a:spcPts val="0"/>
-                        </a:spcBef>
-                        <a:spcAft>
-                          <a:spcPts val="0"/>
-                        </a:spcAft>
-                        <a:buClr>
-                          <a:srgbClr val="000000"/>
-                        </a:buClr>
-                        <a:buSzPts val="1400"/>
-                        <a:buFont typeface="Arial"/>
-                        <a:buNone/>
-                      </a:pPr>
-                      <a:r>
-                        <a:t/>
-                      </a:r>
-                      <a:endParaRPr sz="1400" u="none" cap="none" strike="noStrike"/>
-                    </a:p>
-                  </a:txBody>
-                  <a:tcPr marT="45725" marB="45725" marR="91450" marL="91450"/>
-                </a:tc>
-                <a:tc>
-                  <a:txBody>
-                    <a:bodyPr/>
-                    <a:lstStyle/>
-                    <a:p>
-                      <a:pPr indent="0" lvl="0" marL="0" marR="0" rtl="0" algn="l">
-                        <a:lnSpc>
-                          <a:spcPct val="100000"/>
-                        </a:lnSpc>
-                        <a:spcBef>
-                          <a:spcPts val="0"/>
-                        </a:spcBef>
-                        <a:spcAft>
-                          <a:spcPts val="0"/>
-                        </a:spcAft>
-                        <a:buClr>
-                          <a:srgbClr val="000000"/>
-                        </a:buClr>
-                        <a:buSzPts val="1400"/>
-                        <a:buFont typeface="Arial"/>
-                        <a:buNone/>
-                      </a:pPr>
-                      <a:r>
-                        <a:t/>
-                      </a:r>
-                      <a:endParaRPr sz="1400" u="none" cap="none" strike="noStrike"/>
-                    </a:p>
-                  </a:txBody>
-                  <a:tcPr marT="45725" marB="45725" marR="91450" marL="91450"/>
-                </a:tc>
-                <a:tc>
-                  <a:txBody>
-                    <a:bodyPr/>
-                    <a:lstStyle/>
-                    <a:p>
-                      <a:pPr indent="0" lvl="0" marL="0" marR="0" rtl="0" algn="l">
-                        <a:lnSpc>
-                          <a:spcPct val="100000"/>
-                        </a:lnSpc>
-                        <a:spcBef>
-                          <a:spcPts val="0"/>
-                        </a:spcBef>
-                        <a:spcAft>
-                          <a:spcPts val="0"/>
-                        </a:spcAft>
-                        <a:buClr>
-                          <a:srgbClr val="000000"/>
-                        </a:buClr>
-                        <a:buSzPts val="1400"/>
-                        <a:buFont typeface="Arial"/>
-                        <a:buNone/>
-                      </a:pPr>
-                      <a:r>
-                        <a:t/>
-                      </a:r>
-                      <a:endParaRPr sz="1400" u="none" cap="none" strike="noStrike"/>
-                    </a:p>
-                  </a:txBody>
-                  <a:tcPr marT="45725" marB="45725" marR="91450" marL="91450"/>
-                </a:tc>
-                <a:tc>
-                  <a:txBody>
-                    <a:bodyPr/>
-                    <a:lstStyle/>
-                    <a:p>
-                      <a:pPr indent="0" lvl="0" marL="0" marR="0" rtl="0" algn="l">
-                        <a:lnSpc>
-                          <a:spcPct val="100000"/>
-                        </a:lnSpc>
-                        <a:spcBef>
-                          <a:spcPts val="0"/>
-                        </a:spcBef>
-                        <a:spcAft>
-                          <a:spcPts val="0"/>
-                        </a:spcAft>
-                        <a:buClr>
-                          <a:srgbClr val="000000"/>
-                        </a:buClr>
-                        <a:buSzPts val="1400"/>
-                        <a:buFont typeface="Arial"/>
-                        <a:buNone/>
-                      </a:pPr>
-                      <a:r>
-                        <a:t/>
-                      </a:r>
-                      <a:endParaRPr sz="1400" u="none" cap="none" strike="noStrike"/>
-                    </a:p>
-                  </a:txBody>
-                  <a:tcPr marT="45725" marB="45725" marR="91450" marL="91450"/>
-                </a:tc>
-                <a:tc>
-                  <a:txBody>
-                    <a:bodyPr/>
-                    <a:lstStyle/>
-                    <a:p>
-                      <a:pPr indent="0" lvl="0" marL="0" marR="0" rtl="0" algn="l">
-                        <a:lnSpc>
-                          <a:spcPct val="100000"/>
-                        </a:lnSpc>
-                        <a:spcBef>
-                          <a:spcPts val="0"/>
-                        </a:spcBef>
-                        <a:spcAft>
-                          <a:spcPts val="0"/>
-                        </a:spcAft>
-                        <a:buClr>
-                          <a:srgbClr val="000000"/>
-                        </a:buClr>
-                        <a:buSzPts val="1400"/>
-                        <a:buFont typeface="Arial"/>
-                        <a:buNone/>
-                      </a:pPr>
-                      <a:r>
-                        <a:t/>
-                      </a:r>
-                      <a:endParaRPr sz="1400" u="none" cap="none" strike="noStrike"/>
-                    </a:p>
+                    <a:p/>
                   </a:txBody>
                   <a:tcPr marT="45725" marB="45725" marR="91450" marL="91450"/>
                 </a:tc>
@@ -20024,59 +19387,6 @@
       </p:grpSpPr>
       <p:sp>
         <p:nvSpPr>
-          <p:cNvPr id="143" name="Google Shape;143;g25ace02ada9_0_88"/>
-          <p:cNvSpPr txBox="1"/>
-          <p:nvPr>
-            <p:ph idx="1" type="body"/>
-          </p:nvPr>
-        </p:nvSpPr>
-        <p:spPr>
-          <a:xfrm>
-            <a:off x="881062" y="1425575"/>
-            <a:ext cx="10515600" cy="1019100"/>
-          </a:xfrm>
-          <a:prstGeom prst="rect">
-            <a:avLst/>
-          </a:prstGeom>
-          <a:noFill/>
-          <a:ln>
-            <a:noFill/>
-          </a:ln>
-        </p:spPr>
-        <p:txBody>
-          <a:bodyPr anchorCtr="0" anchor="t" bIns="45700" lIns="91425" spcFirstLastPara="1" rIns="91425" wrap="square" tIns="45700">
-            <a:normAutofit/>
-          </a:bodyPr>
-          <a:lstStyle/>
-          <a:p>
-            <a:pPr indent="0" lvl="0" marL="0" rtl="0" algn="l">
-              <a:lnSpc>
-                <a:spcPct val="90000"/>
-              </a:lnSpc>
-              <a:spcBef>
-                <a:spcPts val="1000"/>
-              </a:spcBef>
-              <a:spcAft>
-                <a:spcPts val="0"/>
-              </a:spcAft>
-              <a:buClr>
-                <a:schemeClr val="dk1"/>
-              </a:buClr>
-              <a:buSzPts val="1100"/>
-              <a:buFont typeface="Arial"/>
-              <a:buNone/>
-              <a:defRPr sz="1300"/>
-            </a:pPr>
-            <a:r>
-              <a:rPr sz="1600"/>
-              <a:t>Funding so far: not yet secured. Nuke Labs is committed as the industry partner for build facilities, field access and TRL 6+ validation.</a:t>
-            </a:r>
-            <a:endParaRPr sz="2000"/>
-          </a:p>
-        </p:txBody>
-      </p:sp>
-      <p:sp>
-        <p:nvSpPr>
           <p:cNvPr id="144" name="Google Shape;144;g25ace02ada9_0_88"/>
           <p:cNvSpPr txBox="1"/>
           <p:nvPr/>
@@ -20130,6 +19440,40 @@
               <a:cs typeface="Arial"/>
               <a:sym typeface="Arial"/>
             </a:endParaRPr>
+          </a:p>
+        </p:txBody>
+      </p:sp>
+      <p:sp>
+        <p:nvSpPr>
+          <p:cNvPr id="145" name="TextBox 144"/>
+          <p:cNvSpPr txBox="1"/>
+          <p:nvPr/>
+        </p:nvSpPr>
+        <p:spPr>
+          <a:xfrm>
+            <a:off x="777240" y="1325880"/>
+            <a:ext cx="10607040" cy="4206240"/>
+          </a:xfrm>
+          <a:prstGeom prst="rect">
+            <a:avLst/>
+          </a:prstGeom>
+          <a:noFill/>
+        </p:spPr>
+        <p:txBody>
+          <a:bodyPr wrap="square">
+            <a:spAutoFit/>
+          </a:bodyPr>
+          <a:lstStyle/>
+          <a:p>
+            <a:pPr>
+              <a:spcAft>
+                <a:spcPts val="800"/>
+              </a:spcAft>
+              <a:defRPr sz="1800"/>
+            </a:pPr>
+            <a:r>
+              <a:t>Funding so far: not yet secured. Nuke Labs is committed as the industry partner for build facilities, field access and TRL 6+ validation.</a:t>
+            </a:r>
           </a:p>
         </p:txBody>
       </p:sp>
@@ -20167,71 +19511,6 @@
       </p:grpSpPr>
       <p:sp>
         <p:nvSpPr>
-          <p:cNvPr id="149" name="Google Shape;149;g25ace02ada9_0_59"/>
-          <p:cNvSpPr txBox="1"/>
-          <p:nvPr>
-            <p:ph idx="1" type="body"/>
-          </p:nvPr>
-        </p:nvSpPr>
-        <p:spPr>
-          <a:xfrm>
-            <a:off x="881062" y="1168400"/>
-            <a:ext cx="10515600" cy="4351338"/>
-          </a:xfrm>
-          <a:prstGeom prst="rect">
-            <a:avLst/>
-          </a:prstGeom>
-          <a:noFill/>
-          <a:ln>
-            <a:noFill/>
-          </a:ln>
-        </p:spPr>
-        <p:txBody>
-          <a:bodyPr anchorCtr="0" anchor="t" bIns="45700" lIns="91425" spcFirstLastPara="1" rIns="91425" wrap="square" tIns="45700">
-            <a:normAutofit/>
-          </a:bodyPr>
-          <a:lstStyle/>
-          <a:p>
-            <a:pPr indent="0" lvl="0" marL="0" rtl="0" algn="l">
-              <a:lnSpc>
-                <a:spcPct val="90000"/>
-              </a:lnSpc>
-              <a:spcBef>
-                <a:spcPts val="1000"/>
-              </a:spcBef>
-              <a:spcAft>
-                <a:spcPts val="0"/>
-              </a:spcAft>
-              <a:buSzPts val="1800"/>
-              <a:buNone/>
-              <a:defRPr sz="1300"/>
-            </a:pPr>
-            <a:r>
-              <a:rPr sz="1600"/>
-              <a:t>Team:</a:t>
-            </a:r>
-            <a:endParaRPr sz="2000">
-              <a:solidFill>
-                <a:srgbClr val="888888"/>
-              </a:solidFill>
-            </a:endParaRPr>
-          </a:p>
-          <a:p>
-            <a:r>
-              <a:rPr sz="1600"/>
-              <a:t>Principal Investigator: Dr. Vishnu Vasudev, Department of Electronics and Communication Engineering.</a:t>
-            </a:r>
-          </a:p>
-          <a:p>
-            <a:r>
-              <a:rPr sz="1600"/>
-              <a:t>Industry partner: Nuke Labs - hardware build, field installations, commercialisation.</a:t>
-            </a:r>
-          </a:p>
-        </p:txBody>
-      </p:sp>
-      <p:sp>
-        <p:nvSpPr>
           <p:cNvPr id="150" name="Google Shape;150;g25ace02ada9_0_59"/>
           <p:cNvSpPr txBox="1"/>
           <p:nvPr/>
@@ -20285,6 +19564,62 @@
               <a:cs typeface="Arial"/>
               <a:sym typeface="Arial"/>
             </a:endParaRPr>
+          </a:p>
+        </p:txBody>
+      </p:sp>
+      <p:sp>
+        <p:nvSpPr>
+          <p:cNvPr id="151" name="TextBox 150"/>
+          <p:cNvSpPr txBox="1"/>
+          <p:nvPr/>
+        </p:nvSpPr>
+        <p:spPr>
+          <a:xfrm>
+            <a:off x="777240" y="1325880"/>
+            <a:ext cx="10607040" cy="4206240"/>
+          </a:xfrm>
+          <a:prstGeom prst="rect">
+            <a:avLst/>
+          </a:prstGeom>
+          <a:noFill/>
+        </p:spPr>
+        <p:txBody>
+          <a:bodyPr wrap="square">
+            <a:spAutoFit/>
+          </a:bodyPr>
+          <a:lstStyle/>
+          <a:p>
+            <a:pPr>
+              <a:spcAft>
+                <a:spcPts val="800"/>
+              </a:spcAft>
+              <a:defRPr sz="1800"/>
+            </a:pPr>
+            <a:r>
+              <a:t>Team:</a:t>
+            </a:r>
+          </a:p>
+          <a:p>
+            <a:pPr>
+              <a:spcAft>
+                <a:spcPts val="800"/>
+              </a:spcAft>
+              <a:defRPr sz="1800"/>
+            </a:pPr>
+            <a:r>
+              <a:t>Principal Investigator: Dr. Vishnu Vasudev, Department of Electronics and Communication Engineering.</a:t>
+            </a:r>
+          </a:p>
+          <a:p>
+            <a:pPr>
+              <a:spcAft>
+                <a:spcPts val="800"/>
+              </a:spcAft>
+              <a:defRPr sz="1800"/>
+            </a:pPr>
+            <a:r>
+              <a:t>Industry partner: Nuke Labs — hardware build, field installations, commercialisation.</a:t>
+            </a:r>
           </a:p>
         </p:txBody>
       </p:sp>
@@ -20364,8 +19699,7 @@
               <a:defRPr sz="1400" b="1"/>
             </a:pPr>
             <a:r>
-              <a:rPr sz="1600"/>
-              <a:t>TankGuard turns tank maintenance from calendar guesswork into measured care: sensing at the edge, deciding locally, cleaning selectively, and showing its own evidence.</a:t>
+              <a:t>Conclusion</a:t>
             </a:r>
             <a:endParaRPr b="1" i="0" sz="2800" u="none" cap="none" strike="noStrike">
               <a:solidFill>
@@ -20376,6 +19710,40 @@
               <a:cs typeface="Arial"/>
               <a:sym typeface="Arial"/>
             </a:endParaRPr>
+          </a:p>
+        </p:txBody>
+      </p:sp>
+      <p:sp>
+        <p:nvSpPr>
+          <p:cNvPr id="156" name="TextBox 155"/>
+          <p:cNvSpPr txBox="1"/>
+          <p:nvPr/>
+        </p:nvSpPr>
+        <p:spPr>
+          <a:xfrm>
+            <a:off x="777240" y="1325880"/>
+            <a:ext cx="10607040" cy="4206240"/>
+          </a:xfrm>
+          <a:prstGeom prst="rect">
+            <a:avLst/>
+          </a:prstGeom>
+          <a:noFill/>
+        </p:spPr>
+        <p:txBody>
+          <a:bodyPr wrap="square">
+            <a:spAutoFit/>
+          </a:bodyPr>
+          <a:lstStyle/>
+          <a:p>
+            <a:pPr>
+              <a:spcAft>
+                <a:spcPts val="800"/>
+              </a:spcAft>
+              <a:defRPr sz="1800"/>
+            </a:pPr>
+            <a:r>
+              <a:t>TankGuard turns tank maintenance from calendar guesswork into measured care: sensing at the edge, deciding locally, cleaning selectively, and showing its own evidence.</a:t>
+            </a:r>
           </a:p>
         </p:txBody>
       </p:sp>
@@ -20458,92 +19826,6 @@
       </p:grpSpPr>
       <p:sp>
         <p:nvSpPr>
-          <p:cNvPr id="87" name="Google Shape;87;p2"/>
-          <p:cNvSpPr txBox="1"/>
-          <p:nvPr>
-            <p:ph idx="1" type="body"/>
-          </p:nvPr>
-        </p:nvSpPr>
-        <p:spPr>
-          <a:xfrm>
-            <a:off x="411701" y="1171921"/>
-            <a:ext cx="11368598" cy="5990670"/>
-          </a:xfrm>
-          <a:prstGeom prst="rect">
-            <a:avLst/>
-          </a:prstGeom>
-          <a:noFill/>
-          <a:ln>
-            <a:noFill/>
-          </a:ln>
-        </p:spPr>
-        <p:txBody>
-          <a:bodyPr anchorCtr="0" anchor="t" bIns="45700" lIns="91425" spcFirstLastPara="1" rIns="91425" wrap="square" tIns="45700">
-            <a:normAutofit/>
-          </a:bodyPr>
-          <a:lstStyle/>
-          <a:p>
-            <a:pPr indent="-342900" lvl="0" marL="457200" rtl="0" algn="l">
-              <a:lnSpc>
-                <a:spcPct val="90000"/>
-              </a:lnSpc>
-              <a:spcBef>
-                <a:spcPts val="1000"/>
-              </a:spcBef>
-              <a:spcAft>
-                <a:spcPts val="0"/>
-              </a:spcAft>
-              <a:buClr>
-                <a:srgbClr val="888888"/>
-              </a:buClr>
-              <a:buSzPts val="1800"/>
-              <a:buChar char="•"/>
-              <a:defRPr sz="1800" b="1"/>
-            </a:pPr>
-            <a:r>
-              <a:rPr sz="1600"/>
-              <a:t>Key Points:</a:t>
-            </a:r>
-            <a:endParaRPr sz="2000">
-              <a:solidFill>
-                <a:srgbClr val="888888"/>
-              </a:solidFill>
-            </a:endParaRPr>
-          </a:p>
-          <a:p>
-            <a:r>
-              <a:rPr sz="1600"/>
-              <a:t>- Three local units, one LAN: M1 monitor, H1 home display + pump control, C1 cleaning arm.</a:t>
-            </a:r>
-          </a:p>
-          <a:p>
-            <a:r>
-              <a:rPr sz="1600"/>
-              <a:t>- Edge-computed TankScore from five submerged probes; no cloud, no account.</a:t>
-            </a:r>
-          </a:p>
-          <a:p>
-            <a:r>
-              <a:rPr sz="1600"/>
-              <a:t>- Dashboard served by the tank unit itself, over its own Wi-Fi.</a:t>
-            </a:r>
-          </a:p>
-          <a:p>
-            <a:r>
-              <a:rPr sz="1600"/>
-              <a:t>- Cleaning arm covers 90% of the tank floor per cycle and parks at both ends.</a:t>
-            </a:r>
-          </a:p>
-          <a:p>
-            <a:r>
-              <a:rPr sz="1600"/>
-              <a:t>- TRL 6+ in 12 months with three field installations.</a:t>
-            </a:r>
-          </a:p>
-        </p:txBody>
-      </p:sp>
-      <p:sp>
-        <p:nvSpPr>
           <p:cNvPr id="88" name="Google Shape;88;p2"/>
           <p:cNvSpPr txBox="1"/>
           <p:nvPr/>
@@ -20586,7 +19868,7 @@
               <a:defRPr sz="1400" b="1"/>
             </a:pPr>
             <a:r>
-              <a:t>Guidelines</a:t>
+              <a:t>Key Points</a:t>
             </a:r>
             <a:endParaRPr b="1" i="0" sz="2800" u="none" cap="none" strike="noStrike">
               <a:solidFill>
@@ -20597,6 +19879,84 @@
               <a:cs typeface="Arial"/>
               <a:sym typeface="Arial"/>
             </a:endParaRPr>
+          </a:p>
+        </p:txBody>
+      </p:sp>
+      <p:sp>
+        <p:nvSpPr>
+          <p:cNvPr id="89" name="TextBox 88"/>
+          <p:cNvSpPr txBox="1"/>
+          <p:nvPr/>
+        </p:nvSpPr>
+        <p:spPr>
+          <a:xfrm>
+            <a:off x="777240" y="1325880"/>
+            <a:ext cx="10607040" cy="4206240"/>
+          </a:xfrm>
+          <a:prstGeom prst="rect">
+            <a:avLst/>
+          </a:prstGeom>
+          <a:noFill/>
+        </p:spPr>
+        <p:txBody>
+          <a:bodyPr wrap="square">
+            <a:spAutoFit/>
+          </a:bodyPr>
+          <a:lstStyle/>
+          <a:p>
+            <a:pPr>
+              <a:spcAft>
+                <a:spcPts val="800"/>
+              </a:spcAft>
+              <a:defRPr sz="1800"/>
+            </a:pPr>
+            <a:r>
+              <a:t>Three local units, one LAN: M1 monitor, H1 home display + pump control, C1 cleaning arm.</a:t>
+            </a:r>
+          </a:p>
+          <a:p>
+            <a:pPr>
+              <a:spcAft>
+                <a:spcPts val="800"/>
+              </a:spcAft>
+              <a:defRPr sz="1800"/>
+            </a:pPr>
+            <a:r>
+              <a:t>Edge-computed TankScore from five submerged probes; no cloud, no account.</a:t>
+            </a:r>
+          </a:p>
+          <a:p>
+            <a:pPr>
+              <a:spcAft>
+                <a:spcPts val="800"/>
+              </a:spcAft>
+              <a:defRPr sz="1800"/>
+            </a:pPr>
+            <a:r>
+              <a:t>Dashboard served by the tank unit itself, over its own Wi-Fi.</a:t>
+            </a:r>
+          </a:p>
+          <a:p>
+            <a:pPr>
+              <a:spcAft>
+                <a:spcPts val="800"/>
+              </a:spcAft>
+              <a:defRPr sz="1800"/>
+            </a:pPr>
+            <a:r>
+              <a:t>Cleaning arm covers 90% of the tank floor per cycle and parks at both ends.</a:t>
+            </a:r>
+          </a:p>
+          <a:p>
+            <a:pPr>
+              <a:spcAft>
+                <a:spcPts val="800"/>
+              </a:spcAft>
+              <a:defRPr sz="1800"/>
+            </a:pPr>
+            <a:r>
+              <a:t>TRL 6+ in 12 months with three field installations.</a:t>
+            </a:r>
           </a:p>
         </p:txBody>
       </p:sp>
@@ -20634,63 +19994,6 @@
       </p:grpSpPr>
       <p:sp>
         <p:nvSpPr>
-          <p:cNvPr id="93" name="Google Shape;93;g25ace02ada9_0_0"/>
-          <p:cNvSpPr txBox="1"/>
-          <p:nvPr>
-            <p:ph idx="1" type="body"/>
-          </p:nvPr>
-        </p:nvSpPr>
-        <p:spPr>
-          <a:xfrm>
-            <a:off x="492100" y="1113850"/>
-            <a:ext cx="10515600" cy="4351200"/>
-          </a:xfrm>
-          <a:prstGeom prst="rect">
-            <a:avLst/>
-          </a:prstGeom>
-          <a:noFill/>
-          <a:ln>
-            <a:noFill/>
-          </a:ln>
-        </p:spPr>
-        <p:txBody>
-          <a:bodyPr anchorCtr="0" anchor="t" bIns="45700" lIns="91425" spcFirstLastPara="1" rIns="91425" wrap="square" tIns="45700">
-            <a:normAutofit/>
-          </a:bodyPr>
-          <a:lstStyle/>
-          <a:p>
-            <a:pPr indent="0" lvl="0" marL="0" rtl="0" algn="l">
-              <a:lnSpc>
-                <a:spcPct val="90000"/>
-              </a:lnSpc>
-              <a:spcBef>
-                <a:spcPts val="1000"/>
-              </a:spcBef>
-              <a:spcAft>
-                <a:spcPts val="0"/>
-              </a:spcAft>
-              <a:buClr>
-                <a:schemeClr val="dk1"/>
-              </a:buClr>
-              <a:buSzPts val="1100"/>
-              <a:buFont typeface="Arial"/>
-              <a:buNone/>
-              <a:defRPr sz="1400"/>
-            </a:pPr>
-            <a:r>
-              <a:rPr sz="1600"/>
-              <a:t>Water storage tanks degrade silently: disinfectant residual dissipates within 24-48 hours, particles settle into a sludge layer, biofilm forms on the walls, and algae bloom in warm water. By the time the water smells or looks wrong it is unsafe, and the only remedy is a full drain and manual scrub that wastes the whole stored volume.</a:t>
-            </a:r>
-            <a:endParaRPr sz="2000">
-              <a:solidFill>
-                <a:srgbClr val="888888"/>
-              </a:solidFill>
-            </a:endParaRPr>
-          </a:p>
-        </p:txBody>
-      </p:sp>
-      <p:sp>
-        <p:nvSpPr>
           <p:cNvPr id="94" name="Google Shape;94;g25ace02ada9_0_0"/>
           <p:cNvSpPr txBox="1"/>
           <p:nvPr/>
@@ -20744,6 +20047,40 @@
               <a:cs typeface="Arial"/>
               <a:sym typeface="Arial"/>
             </a:endParaRPr>
+          </a:p>
+        </p:txBody>
+      </p:sp>
+      <p:sp>
+        <p:nvSpPr>
+          <p:cNvPr id="95" name="TextBox 94"/>
+          <p:cNvSpPr txBox="1"/>
+          <p:nvPr/>
+        </p:nvSpPr>
+        <p:spPr>
+          <a:xfrm>
+            <a:off x="777240" y="1325880"/>
+            <a:ext cx="10607040" cy="4206240"/>
+          </a:xfrm>
+          <a:prstGeom prst="rect">
+            <a:avLst/>
+          </a:prstGeom>
+          <a:noFill/>
+        </p:spPr>
+        <p:txBody>
+          <a:bodyPr wrap="square">
+            <a:spAutoFit/>
+          </a:bodyPr>
+          <a:lstStyle/>
+          <a:p>
+            <a:pPr>
+              <a:spcAft>
+                <a:spcPts val="800"/>
+              </a:spcAft>
+              <a:defRPr sz="1800"/>
+            </a:pPr>
+            <a:r>
+              <a:t>Water storage tanks degrade silently: disinfectant residual dissipates within 24-48 hours, particles settle into a sludge layer, biofilm forms on the walls, and algae bloom in warm water. By the time the water smells or looks wrong it is unsafe, and the only remedy is a full drain and manual scrub that wastes the whole stored volume.</a:t>
+            </a:r>
           </a:p>
         </p:txBody>
       </p:sp>
@@ -20781,55 +20118,6 @@
       </p:grpSpPr>
       <p:sp>
         <p:nvSpPr>
-          <p:cNvPr id="99" name="Google Shape;99;g25ace02ada9_0_5"/>
-          <p:cNvSpPr txBox="1"/>
-          <p:nvPr>
-            <p:ph idx="1" type="body"/>
-          </p:nvPr>
-        </p:nvSpPr>
-        <p:spPr>
-          <a:xfrm>
-            <a:off x="881062" y="988075"/>
-            <a:ext cx="10515600" cy="1244100"/>
-          </a:xfrm>
-          <a:prstGeom prst="rect">
-            <a:avLst/>
-          </a:prstGeom>
-          <a:noFill/>
-          <a:ln>
-            <a:noFill/>
-          </a:ln>
-        </p:spPr>
-        <p:txBody>
-          <a:bodyPr anchorCtr="0" anchor="t" bIns="45700" lIns="91425" spcFirstLastPara="1" rIns="91425" wrap="square" tIns="45700">
-            <a:normAutofit/>
-          </a:bodyPr>
-          <a:lstStyle/>
-          <a:p>
-            <a:pPr indent="0" lvl="0" marL="0" rtl="0" algn="l">
-              <a:lnSpc>
-                <a:spcPct val="90000"/>
-              </a:lnSpc>
-              <a:spcBef>
-                <a:spcPts val="1000"/>
-              </a:spcBef>
-              <a:spcAft>
-                <a:spcPts val="0"/>
-              </a:spcAft>
-              <a:buSzPts val="1800"/>
-              <a:buNone/>
-              <a:defRPr sz="1400"/>
-            </a:pPr>
-            <a:r>
-              <a:rPr sz="1600"/>
-              <a:t>M1 sits on the lid: five submerged probes through an ADS1115, an edge TankScore, and a web dashboard served from its own flash. H1 sits by the pump: a 1.8" display, automatic level control through an isolated relay and contactor, and a manual override. C1 is a two-link 20 cm + 20 cm arm that sweeps three concentric rings with a ring brush and draws the loosened sludge out through the centre of the head.</a:t>
-            </a:r>
-            <a:endParaRPr/>
-          </a:p>
-        </p:txBody>
-      </p:sp>
-      <p:sp>
-        <p:nvSpPr>
           <p:cNvPr id="100" name="Google Shape;100;g25ace02ada9_0_5"/>
           <p:cNvSpPr txBox="1"/>
           <p:nvPr/>
@@ -20883,6 +20171,40 @@
               <a:cs typeface="Arial"/>
               <a:sym typeface="Arial"/>
             </a:endParaRPr>
+          </a:p>
+        </p:txBody>
+      </p:sp>
+      <p:sp>
+        <p:nvSpPr>
+          <p:cNvPr id="101" name="TextBox 100"/>
+          <p:cNvSpPr txBox="1"/>
+          <p:nvPr/>
+        </p:nvSpPr>
+        <p:spPr>
+          <a:xfrm>
+            <a:off x="777240" y="1325880"/>
+            <a:ext cx="10607040" cy="4206240"/>
+          </a:xfrm>
+          <a:prstGeom prst="rect">
+            <a:avLst/>
+          </a:prstGeom>
+          <a:noFill/>
+        </p:spPr>
+        <p:txBody>
+          <a:bodyPr wrap="square">
+            <a:spAutoFit/>
+          </a:bodyPr>
+          <a:lstStyle/>
+          <a:p>
+            <a:pPr>
+              <a:spcAft>
+                <a:spcPts val="800"/>
+              </a:spcAft>
+              <a:defRPr sz="1800"/>
+            </a:pPr>
+            <a:r>
+              <a:t>M1 sits on the lid: five submerged probes through an ADS1115, an edge TankScore, and a web dashboard served from its own flash. H1 sits by the pump: a 1.8-inch display, automatic level control through an isolated relay and contactor, and a manual override. C1 is a two-link 20 cm + 20 cm arm that sweeps three concentric rings with a ring brush and draws the loosened sludge out through the centre of the head.</a:t>
+            </a:r>
           </a:p>
         </p:txBody>
       </p:sp>
@@ -20920,79 +20242,6 @@
       </p:grpSpPr>
       <p:sp>
         <p:nvSpPr>
-          <p:cNvPr id="105" name="Google Shape;105;p15"/>
-          <p:cNvSpPr txBox="1"/>
-          <p:nvPr>
-            <p:ph idx="1" type="body"/>
-          </p:nvPr>
-        </p:nvSpPr>
-        <p:spPr>
-          <a:xfrm>
-            <a:off x="881062" y="988075"/>
-            <a:ext cx="10515600" cy="1244100"/>
-          </a:xfrm>
-          <a:prstGeom prst="rect">
-            <a:avLst/>
-          </a:prstGeom>
-          <a:noFill/>
-          <a:ln>
-            <a:noFill/>
-          </a:ln>
-        </p:spPr>
-        <p:txBody>
-          <a:bodyPr anchorCtr="0" anchor="t" bIns="45700" lIns="91425" spcFirstLastPara="1" rIns="91425" wrap="square" tIns="45700">
-            <a:normAutofit/>
-          </a:bodyPr>
-          <a:lstStyle/>
-          <a:p>
-            <a:pPr indent="0" lvl="0" marL="0" rtl="0" algn="l">
-              <a:lnSpc>
-                <a:spcPct val="90000"/>
-              </a:lnSpc>
-              <a:spcBef>
-                <a:spcPts val="1000"/>
-              </a:spcBef>
-              <a:spcAft>
-                <a:spcPts val="0"/>
-              </a:spcAft>
-              <a:buSzPts val="1800"/>
-              <a:buNone/>
-              <a:defRPr sz="1300"/>
-            </a:pPr>
-            <a:r>
-              <a:rPr sz="1600"/>
-              <a:t>Unique points:</a:t>
-            </a:r>
-            <a:endParaRPr/>
-          </a:p>
-          <a:p>
-            <a:r>
-              <a:rPr sz="1600"/>
-              <a:t>1. Closed-loop care: sense, score, act, verify - with the verification shown, not claimed.</a:t>
-            </a:r>
-          </a:p>
-          <a:p>
-            <a:r>
-              <a:rPr sz="1600"/>
-              <a:t>2. Local-only architecture: no cloud path, no account, works when the internet does not.</a:t>
-            </a:r>
-          </a:p>
-          <a:p>
-            <a:r>
-              <a:rPr sz="1600"/>
-              <a:t>3. Selective cleaning: 90% floor coverage per cycle without draining the tank.</a:t>
-            </a:r>
-          </a:p>
-          <a:p>
-            <a:r>
-              <a:rPr sz="1600"/>
-              <a:t>4. Honest instrumentation: the dashboard states its data source and the arm's 2 cm wall ring.</a:t>
-            </a:r>
-          </a:p>
-        </p:txBody>
-      </p:sp>
-      <p:sp>
-        <p:nvSpPr>
           <p:cNvPr id="106" name="Google Shape;106;p15"/>
           <p:cNvSpPr txBox="1"/>
           <p:nvPr/>
@@ -21046,6 +20295,84 @@
               <a:cs typeface="Arial"/>
               <a:sym typeface="Arial"/>
             </a:endParaRPr>
+          </a:p>
+        </p:txBody>
+      </p:sp>
+      <p:sp>
+        <p:nvSpPr>
+          <p:cNvPr id="107" name="TextBox 106"/>
+          <p:cNvSpPr txBox="1"/>
+          <p:nvPr/>
+        </p:nvSpPr>
+        <p:spPr>
+          <a:xfrm>
+            <a:off x="777240" y="1325880"/>
+            <a:ext cx="10607040" cy="4206240"/>
+          </a:xfrm>
+          <a:prstGeom prst="rect">
+            <a:avLst/>
+          </a:prstGeom>
+          <a:noFill/>
+        </p:spPr>
+        <p:txBody>
+          <a:bodyPr wrap="square">
+            <a:spAutoFit/>
+          </a:bodyPr>
+          <a:lstStyle/>
+          <a:p>
+            <a:pPr>
+              <a:spcAft>
+                <a:spcPts val="800"/>
+              </a:spcAft>
+              <a:defRPr sz="1800"/>
+            </a:pPr>
+            <a:r>
+              <a:t>Unique points:</a:t>
+            </a:r>
+          </a:p>
+          <a:p>
+            <a:pPr>
+              <a:spcAft>
+                <a:spcPts val="800"/>
+              </a:spcAft>
+              <a:defRPr sz="1800"/>
+            </a:pPr>
+            <a:r>
+              <a:t>1. Closed-loop care: sense, score, act, verify — with the verification shown, not claimed.</a:t>
+            </a:r>
+          </a:p>
+          <a:p>
+            <a:pPr>
+              <a:spcAft>
+                <a:spcPts val="800"/>
+              </a:spcAft>
+              <a:defRPr sz="1800"/>
+            </a:pPr>
+            <a:r>
+              <a:t>2. Local-only architecture: no cloud path, no account, works when the internet does not.</a:t>
+            </a:r>
+          </a:p>
+          <a:p>
+            <a:pPr>
+              <a:spcAft>
+                <a:spcPts val="800"/>
+              </a:spcAft>
+              <a:defRPr sz="1800"/>
+            </a:pPr>
+            <a:r>
+              <a:t>3. Selective cleaning: 90% floor coverage per cycle without draining the tank.</a:t>
+            </a:r>
+          </a:p>
+          <a:p>
+            <a:pPr>
+              <a:spcAft>
+                <a:spcPts val="800"/>
+              </a:spcAft>
+              <a:defRPr sz="1800"/>
+            </a:pPr>
+            <a:r>
+              <a:t>4. Honest instrumentation: the dashboard states its data source and the arm's 2 cm wall ring.</a:t>
+            </a:r>
           </a:p>
         </p:txBody>
       </p:sp>
@@ -21076,79 +20403,6 @@
       </p:grpSpPr>
       <p:sp>
         <p:nvSpPr>
-          <p:cNvPr id="111" name="Google Shape;111;g25ace02ada9_0_22"/>
-          <p:cNvSpPr txBox="1"/>
-          <p:nvPr>
-            <p:ph idx="1" type="body"/>
-          </p:nvPr>
-        </p:nvSpPr>
-        <p:spPr>
-          <a:xfrm>
-            <a:off x="666750" y="1149350"/>
-            <a:ext cx="10515600" cy="4351200"/>
-          </a:xfrm>
-          <a:prstGeom prst="rect">
-            <a:avLst/>
-          </a:prstGeom>
-          <a:noFill/>
-          <a:ln>
-            <a:noFill/>
-          </a:ln>
-        </p:spPr>
-        <p:txBody>
-          <a:bodyPr anchorCtr="0" anchor="t" bIns="45700" lIns="91425" spcFirstLastPara="1" rIns="91425" wrap="square" tIns="45700">
-            <a:normAutofit/>
-          </a:bodyPr>
-          <a:lstStyle/>
-          <a:p>
-            <a:pPr indent="0" lvl="0" marL="0" rtl="0" algn="l">
-              <a:lnSpc>
-                <a:spcPct val="90000"/>
-              </a:lnSpc>
-              <a:spcBef>
-                <a:spcPts val="1000"/>
-              </a:spcBef>
-              <a:spcAft>
-                <a:spcPts val="0"/>
-              </a:spcAft>
-              <a:buSzPts val="1800"/>
-              <a:buNone/>
-              <a:defRPr sz="1300"/>
-            </a:pPr>
-            <a:r>
-              <a:rPr sz="1600"/>
-              <a:t>Quantified impact:</a:t>
-            </a:r>
-            <a:endParaRPr/>
-          </a:p>
-          <a:p>
-            <a:r>
-              <a:rPr sz="1600"/>
-              <a:t>- No full drain: cleaning removes the sludge layer, not the stored volume.</a:t>
-            </a:r>
-          </a:p>
-          <a:p>
-            <a:r>
-              <a:rPr sz="1600"/>
-              <a:t>- Pump protection: level-based automatic control with a safe manual override.</a:t>
-            </a:r>
-          </a:p>
-          <a:p>
-            <a:r>
-              <a:rPr sz="1600"/>
-              <a:t>- Early warning: a score trend catches degradation before smell or taste.</a:t>
-            </a:r>
-          </a:p>
-          <a:p>
-            <a:r>
-              <a:rPr sz="1600"/>
-              <a:t>- Off-grid: solar + battery keeps the monitor alive for weeks without sun.</a:t>
-            </a:r>
-          </a:p>
-        </p:txBody>
-      </p:sp>
-      <p:sp>
-        <p:nvSpPr>
           <p:cNvPr id="112" name="Google Shape;112;g25ace02ada9_0_22"/>
           <p:cNvSpPr txBox="1"/>
           <p:nvPr/>
@@ -21202,6 +20456,84 @@
               <a:cs typeface="Arial"/>
               <a:sym typeface="Arial"/>
             </a:endParaRPr>
+          </a:p>
+        </p:txBody>
+      </p:sp>
+      <p:sp>
+        <p:nvSpPr>
+          <p:cNvPr id="113" name="TextBox 112"/>
+          <p:cNvSpPr txBox="1"/>
+          <p:nvPr/>
+        </p:nvSpPr>
+        <p:spPr>
+          <a:xfrm>
+            <a:off x="777240" y="1325880"/>
+            <a:ext cx="10607040" cy="4206240"/>
+          </a:xfrm>
+          <a:prstGeom prst="rect">
+            <a:avLst/>
+          </a:prstGeom>
+          <a:noFill/>
+        </p:spPr>
+        <p:txBody>
+          <a:bodyPr wrap="square">
+            <a:spAutoFit/>
+          </a:bodyPr>
+          <a:lstStyle/>
+          <a:p>
+            <a:pPr>
+              <a:spcAft>
+                <a:spcPts val="800"/>
+              </a:spcAft>
+              <a:defRPr sz="1800"/>
+            </a:pPr>
+            <a:r>
+              <a:t>Quantified impact:</a:t>
+            </a:r>
+          </a:p>
+          <a:p>
+            <a:pPr>
+              <a:spcAft>
+                <a:spcPts val="800"/>
+              </a:spcAft>
+              <a:defRPr sz="1800"/>
+            </a:pPr>
+            <a:r>
+              <a:t>No full drain: cleaning removes the sludge layer, not the stored volume.</a:t>
+            </a:r>
+          </a:p>
+          <a:p>
+            <a:pPr>
+              <a:spcAft>
+                <a:spcPts val="800"/>
+              </a:spcAft>
+              <a:defRPr sz="1800"/>
+            </a:pPr>
+            <a:r>
+              <a:t>Pump protection: level-based automatic control with a safe manual override.</a:t>
+            </a:r>
+          </a:p>
+          <a:p>
+            <a:pPr>
+              <a:spcAft>
+                <a:spcPts val="800"/>
+              </a:spcAft>
+              <a:defRPr sz="1800"/>
+            </a:pPr>
+            <a:r>
+              <a:t>Early warning: a score trend catches degradation before smell or taste.</a:t>
+            </a:r>
+          </a:p>
+          <a:p>
+            <a:pPr>
+              <a:spcAft>
+                <a:spcPts val="800"/>
+              </a:spcAft>
+              <a:defRPr sz="1800"/>
+            </a:pPr>
+            <a:r>
+              <a:t>Off-grid: solar and battery keep the monitor alive for weeks without sun.</a:t>
+            </a:r>
           </a:p>
         </p:txBody>
       </p:sp>
@@ -21232,79 +20564,6 @@
       </p:grpSpPr>
       <p:sp>
         <p:nvSpPr>
-          <p:cNvPr id="117" name="Google Shape;117;g25ace02ada9_0_17"/>
-          <p:cNvSpPr txBox="1"/>
-          <p:nvPr>
-            <p:ph idx="1" type="body"/>
-          </p:nvPr>
-        </p:nvSpPr>
-        <p:spPr>
-          <a:xfrm>
-            <a:off x="554400" y="1383400"/>
-            <a:ext cx="10515600" cy="5109472"/>
-          </a:xfrm>
-          <a:prstGeom prst="rect">
-            <a:avLst/>
-          </a:prstGeom>
-          <a:noFill/>
-          <a:ln>
-            <a:noFill/>
-          </a:ln>
-        </p:spPr>
-        <p:txBody>
-          <a:bodyPr anchorCtr="0" anchor="t" bIns="45700" lIns="91425" spcFirstLastPara="1" rIns="91425" wrap="square" tIns="45700">
-            <a:normAutofit/>
-          </a:bodyPr>
-          <a:lstStyle/>
-          <a:p>
-            <a:pPr indent="0" lvl="0" marL="0" rtl="0" algn="l">
-              <a:lnSpc>
-                <a:spcPct val="90000"/>
-              </a:lnSpc>
-              <a:spcBef>
-                <a:spcPts val="1000"/>
-              </a:spcBef>
-              <a:spcAft>
-                <a:spcPts val="0"/>
-              </a:spcAft>
-              <a:buSzPts val="1800"/>
-              <a:buNone/>
-              <a:defRPr sz="1300"/>
-            </a:pPr>
-            <a:r>
-              <a:rPr sz="1600"/>
-              <a:t>Methodology:</a:t>
-            </a:r>
-            <a:endParaRPr/>
-          </a:p>
-          <a:p>
-            <a:r>
-              <a:rPr sz="1600"/>
-              <a:t>M1 (T0+2): probes, TankScore, dashboard served from flash.</a:t>
-            </a:r>
-          </a:p>
-          <a:p>
-            <a:r>
-              <a:rPr sz="1600"/>
-              <a:t>H1 + dashboard (T0+4): TFT, pump control, session log, device table.</a:t>
-            </a:r>
-          </a:p>
-          <a:p>
-            <a:r>
-              <a:rPr sz="1600"/>
-              <a:t>C1 (T0+8): 2R arm, planner, controller, three-ring cycle.</a:t>
-            </a:r>
-          </a:p>
-          <a:p>
-            <a:r>
-              <a:rPr sz="1600"/>
-              <a:t>Field (T0+12): three installations, 90 days, TRL 6+ evidence.</a:t>
-            </a:r>
-          </a:p>
-        </p:txBody>
-      </p:sp>
-      <p:sp>
-        <p:nvSpPr>
           <p:cNvPr id="118" name="Google Shape;118;g25ace02ada9_0_17"/>
           <p:cNvSpPr txBox="1"/>
           <p:nvPr/>
@@ -21358,6 +20617,84 @@
               <a:cs typeface="Arial"/>
               <a:sym typeface="Arial"/>
             </a:endParaRPr>
+          </a:p>
+        </p:txBody>
+      </p:sp>
+      <p:sp>
+        <p:nvSpPr>
+          <p:cNvPr id="119" name="TextBox 118"/>
+          <p:cNvSpPr txBox="1"/>
+          <p:nvPr/>
+        </p:nvSpPr>
+        <p:spPr>
+          <a:xfrm>
+            <a:off x="777240" y="1325880"/>
+            <a:ext cx="10607040" cy="4206240"/>
+          </a:xfrm>
+          <a:prstGeom prst="rect">
+            <a:avLst/>
+          </a:prstGeom>
+          <a:noFill/>
+        </p:spPr>
+        <p:txBody>
+          <a:bodyPr wrap="square">
+            <a:spAutoFit/>
+          </a:bodyPr>
+          <a:lstStyle/>
+          <a:p>
+            <a:pPr>
+              <a:spcAft>
+                <a:spcPts val="800"/>
+              </a:spcAft>
+              <a:defRPr sz="1800"/>
+            </a:pPr>
+            <a:r>
+              <a:t>Methodology:</a:t>
+            </a:r>
+          </a:p>
+          <a:p>
+            <a:pPr>
+              <a:spcAft>
+                <a:spcPts val="800"/>
+              </a:spcAft>
+              <a:defRPr sz="1800"/>
+            </a:pPr>
+            <a:r>
+              <a:t>M1 (T0+2): probes, TankScore, dashboard served from flash.</a:t>
+            </a:r>
+          </a:p>
+          <a:p>
+            <a:pPr>
+              <a:spcAft>
+                <a:spcPts val="800"/>
+              </a:spcAft>
+              <a:defRPr sz="1800"/>
+            </a:pPr>
+            <a:r>
+              <a:t>H1 + dashboard (T0+4): TFT, pump control, session log, device table.</a:t>
+            </a:r>
+          </a:p>
+          <a:p>
+            <a:pPr>
+              <a:spcAft>
+                <a:spcPts val="800"/>
+              </a:spcAft>
+              <a:defRPr sz="1800"/>
+            </a:pPr>
+            <a:r>
+              <a:t>C1 (T0+8): 2R arm, planner, controller, three-ring cycle.</a:t>
+            </a:r>
+          </a:p>
+          <a:p>
+            <a:pPr>
+              <a:spcAft>
+                <a:spcPts val="800"/>
+              </a:spcAft>
+              <a:defRPr sz="1800"/>
+            </a:pPr>
+            <a:r>
+              <a:t>Field (T0+12): three installations, 90 days, TRL 6+ evidence.</a:t>
+            </a:r>
           </a:p>
         </p:txBody>
       </p:sp>
@@ -21394,7 +20731,7 @@
         </p:nvGraphicFramePr>
         <p:xfrm>
           <a:off x="751114" y="1471990"/>
-          <a:ext cx="3000000" cy="3000000"/>
+          <a:ext cx="3000000" cy="2514600"/>
         </p:xfrm>
         <a:graphic>
           <a:graphicData uri="http://schemas.openxmlformats.org/drawingml/2006/table">
@@ -21408,37 +20745,15 @@
                 <a:gridCol w="4985250"/>
                 <a:gridCol w="3350400"/>
               </a:tblGrid>
-              <a:tr h="553525">
+              <a:tr h="502920">
                 <a:tc>
                   <a:txBody>
                     <a:bodyPr/>
                     <a:lstStyle/>
                     <a:p>
-                      <a:pPr indent="0" lvl="0" marL="0" marR="0" rtl="0" algn="l">
-                        <a:lnSpc>
-                          <a:spcPct val="100000"/>
-                        </a:lnSpc>
-                        <a:spcBef>
-                          <a:spcPts val="0"/>
-                        </a:spcBef>
-                        <a:spcAft>
-                          <a:spcPts val="0"/>
-                        </a:spcAft>
-                        <a:buClr>
-                          <a:srgbClr val="000000"/>
-                        </a:buClr>
-                        <a:buSzPts val="1100"/>
-                        <a:buFont typeface="Arial"/>
-                        <a:buNone/>
-                      </a:pPr>
                       <a:r>
-                        <a:t/>
+                        <a:t>No.</a:t>
                       </a:r>
-                      <a:endParaRPr sz="1100" u="none" cap="none" strike="noStrike">
-                        <a:solidFill>
-                          <a:schemeClr val="dk1"/>
-                        </a:solidFill>
-                      </a:endParaRPr>
                     </a:p>
                   </a:txBody>
                   <a:tcPr marT="45725" marB="45725" marR="91450" marL="91450"/>
@@ -21448,75 +20763,9 @@
                     <a:bodyPr/>
                     <a:lstStyle/>
                     <a:p>
-                      <a:pPr indent="0" lvl="0" marL="0" marR="0" rtl="0" algn="just">
-                        <a:lnSpc>
-                          <a:spcPct val="100000"/>
-                        </a:lnSpc>
-                        <a:spcBef>
-                          <a:spcPts val="0"/>
-                        </a:spcBef>
-                        <a:spcAft>
-                          <a:spcPts val="0"/>
-                        </a:spcAft>
-                        <a:buClr>
-                          <a:srgbClr val="000000"/>
-                        </a:buClr>
-                        <a:buSzPts val="1100"/>
-                        <a:buFont typeface="Arial"/>
-                        <a:buNone/>
-                      </a:pPr>
                       <a:r>
-                        <a:t/>
+                        <a:t>Milestone</a:t>
                       </a:r>
-                      <a:endParaRPr b="1" sz="1100" u="none" cap="none" strike="noStrike">
-                        <a:solidFill>
-                          <a:schemeClr val="dk1"/>
-                        </a:solidFill>
-                        <a:latin typeface="Arial"/>
-                        <a:ea typeface="Arial"/>
-                        <a:cs typeface="Arial"/>
-                        <a:sym typeface="Arial"/>
-                      </a:endParaRPr>
-                    </a:p>
-                    <a:p>
-                      <a:pPr indent="0" lvl="0" marL="0" marR="0" rtl="0" algn="just">
-                        <a:lnSpc>
-                          <a:spcPct val="100000"/>
-                        </a:lnSpc>
-                        <a:spcBef>
-                          <a:spcPts val="500"/>
-                        </a:spcBef>
-                        <a:spcAft>
-                          <a:spcPts val="0"/>
-                        </a:spcAft>
-                        <a:buClr>
-                          <a:srgbClr val="000000"/>
-                        </a:buClr>
-                        <a:buSzPts val="1100"/>
-                        <a:buFont typeface="Arial"/>
-                        <a:buNone/>
-                      </a:pPr>
-                      <a:r>
-                        <a:rPr b="1" lang="en-US" sz="1100" u="none" cap="none" strike="noStrike">
-                          <a:solidFill>
-                            <a:schemeClr val="dk1"/>
-                          </a:solidFill>
-                          <a:latin typeface="Arial"/>
-                          <a:ea typeface="Arial"/>
-                          <a:cs typeface="Arial"/>
-                          <a:sym typeface="Arial"/>
-                        </a:rPr>
-                        <a:t>Milestone Details</a:t>
-                      </a:r>
-                      <a:endParaRPr sz="1100" u="none" cap="none" strike="noStrike">
-                        <a:solidFill>
-                          <a:schemeClr val="dk1"/>
-                        </a:solidFill>
-                        <a:latin typeface="Times New Roman"/>
-                        <a:ea typeface="Times New Roman"/>
-                        <a:cs typeface="Times New Roman"/>
-                        <a:sym typeface="Times New Roman"/>
-                      </a:endParaRPr>
                     </a:p>
                   </a:txBody>
                   <a:tcPr marT="0" marB="0" marR="68575" marL="68575"/>
@@ -21526,81 +20775,15 @@
                     <a:bodyPr/>
                     <a:lstStyle/>
                     <a:p>
-                      <a:pPr indent="0" lvl="0" marL="0" marR="0" rtl="0" algn="just">
-                        <a:lnSpc>
-                          <a:spcPct val="100000"/>
-                        </a:lnSpc>
-                        <a:spcBef>
-                          <a:spcPts val="0"/>
-                        </a:spcBef>
-                        <a:spcAft>
-                          <a:spcPts val="0"/>
-                        </a:spcAft>
-                        <a:buClr>
-                          <a:srgbClr val="000000"/>
-                        </a:buClr>
-                        <a:buSzPts val="1100"/>
-                        <a:buFont typeface="Arial"/>
-                        <a:buNone/>
-                      </a:pPr>
                       <a:r>
-                        <a:t/>
+                        <a:t>Time period</a:t>
                       </a:r>
-                      <a:endParaRPr b="1" sz="1100" u="none" cap="none" strike="noStrike">
-                        <a:solidFill>
-                          <a:schemeClr val="dk1"/>
-                        </a:solidFill>
-                        <a:latin typeface="Arial"/>
-                        <a:ea typeface="Arial"/>
-                        <a:cs typeface="Arial"/>
-                        <a:sym typeface="Arial"/>
-                      </a:endParaRPr>
-                    </a:p>
-                    <a:p>
-                      <a:pPr indent="0" lvl="0" marL="0" marR="0" rtl="0" algn="just">
-                        <a:lnSpc>
-                          <a:spcPct val="100000"/>
-                        </a:lnSpc>
-                        <a:spcBef>
-                          <a:spcPts val="500"/>
-                        </a:spcBef>
-                        <a:spcAft>
-                          <a:spcPts val="0"/>
-                        </a:spcAft>
-                        <a:buClr>
-                          <a:srgbClr val="000000"/>
-                        </a:buClr>
-                        <a:buSzPts val="1100"/>
-                        <a:buFont typeface="Arial"/>
-                        <a:buNone/>
-                      </a:pPr>
-                      <a:r>
-                        <a:rPr b="1" lang="en-US" sz="1100" u="none" cap="none" strike="noStrike">
-                          <a:solidFill>
-                            <a:schemeClr val="dk1"/>
-                          </a:solidFill>
-                          <a:latin typeface="Arial"/>
-                          <a:ea typeface="Arial"/>
-                          <a:cs typeface="Arial"/>
-                          <a:sym typeface="Arial"/>
-                        </a:rPr>
-                        <a:t>Time Period Required from To (To Being Project Start Date)</a:t>
-                      </a:r>
-                      <a:endParaRPr sz="1100" u="none" cap="none" strike="noStrike">
-                        <a:solidFill>
-                          <a:schemeClr val="dk1"/>
-                        </a:solidFill>
-                        <a:latin typeface="Times New Roman"/>
-                        <a:ea typeface="Times New Roman"/>
-                        <a:cs typeface="Times New Roman"/>
-                        <a:sym typeface="Times New Roman"/>
-                      </a:endParaRPr>
                     </a:p>
                   </a:txBody>
                   <a:tcPr marT="0" marB="0" marR="68575" marL="68575"/>
                 </a:tc>
               </a:tr>
-              <a:tr h="1547125">
+              <a:tr h="502920">
                 <a:tc>
                   <a:txBody>
                     <a:bodyPr/>
@@ -21638,7 +20821,7 @@
                   <a:tcPr marT="45725" marB="45725" marR="91450" marL="91450"/>
                 </a:tc>
               </a:tr>
-              <a:tr h="1131450">
+              <a:tr h="502920">
                 <a:tc>
                   <a:txBody>
                     <a:bodyPr/>
@@ -21676,7 +20859,7 @@
                   <a:tcPr marT="45725" marB="45725" marR="91450" marL="91450"/>
                 </a:tc>
               </a:tr>
-              <a:tr h="892850">
+              <a:tr h="502920">
                 <a:tc>
                   <a:txBody>
                     <a:bodyPr/>
@@ -21714,7 +20897,7 @@
                   <a:tcPr marT="45725" marB="45725" marR="91450" marL="91450"/>
                 </a:tc>
               </a:tr>
-              <a:tr h="641925">
+              <a:tr h="502920">
                 <a:tc>
                   <a:txBody>
                     <a:bodyPr/>
@@ -21800,8 +20983,7 @@
               <a:defRPr sz="1400" b="1"/>
             </a:pPr>
             <a:r>
-              <a:rPr sz="1600"/>
-              <a:t>Milestones:</a:t>
+              <a:t>Milestones</a:t>
             </a:r>
             <a:endParaRPr b="1" i="0" sz="2800" u="none" cap="none" strike="noStrike">
               <a:solidFill>
@@ -21812,30 +20994,6 @@
               <a:cs typeface="Arial"/>
               <a:sym typeface="Arial"/>
             </a:endParaRPr>
-          </a:p>
-          <a:p>
-            <a:r>
-              <a:rPr sz="1600"/>
-              <a:t>1  Requirements and monitor prototype - T0 + 2 months</a:t>
-            </a:r>
-          </a:p>
-          <a:p>
-            <a:r>
-              <a:rPr sz="1600"/>
-              <a:t>2  Home unit and dashboard - T0 + 4 months</a:t>
-            </a:r>
-          </a:p>
-          <a:p>
-            <a:r>
-              <a:rPr sz="1600"/>
-              <a:t>3  Cleaning arm - T0 + 8 months</a:t>
-            </a:r>
-          </a:p>
-          <a:p>
-            <a:r>
-              <a:rPr sz="1600"/>
-              <a:t>4  Field validation - T0 + 12 months</a:t>
-            </a:r>
           </a:p>
         </p:txBody>
       </p:sp>
@@ -21866,103 +21024,6 @@
       </p:grpSpPr>
       <p:sp>
         <p:nvSpPr>
-          <p:cNvPr id="129" name="Google Shape;129;g25ace02ada9_0_28"/>
-          <p:cNvSpPr txBox="1"/>
-          <p:nvPr>
-            <p:ph type="title"/>
-          </p:nvPr>
-        </p:nvSpPr>
-        <p:spPr>
-          <a:xfrm>
-            <a:off x="838200" y="365125"/>
-            <a:ext cx="10515600" cy="1325700"/>
-          </a:xfrm>
-          <a:prstGeom prst="rect">
-            <a:avLst/>
-          </a:prstGeom>
-          <a:noFill/>
-          <a:ln>
-            <a:noFill/>
-          </a:ln>
-        </p:spPr>
-        <p:txBody>
-          <a:bodyPr anchorCtr="0" anchor="ctr" bIns="45700" lIns="91425" spcFirstLastPara="1" rIns="91425" wrap="square" tIns="45700">
-            <a:normAutofit/>
-          </a:bodyPr>
-          <a:lstStyle/>
-          <a:p>
-            <a:pPr indent="0" lvl="0" marL="0" rtl="0" algn="l">
-              <a:lnSpc>
-                <a:spcPct val="90000"/>
-              </a:lnSpc>
-              <a:spcBef>
-                <a:spcPts val="0"/>
-              </a:spcBef>
-              <a:spcAft>
-                <a:spcPts val="0"/>
-              </a:spcAft>
-              <a:buSzPts val="1800"/>
-              <a:buNone/>
-            </a:pPr>
-            <a:r>
-              <a:rPr lang="en-US"/>
-              <a:t> </a:t>
-            </a:r>
-            <a:endParaRPr/>
-          </a:p>
-        </p:txBody>
-      </p:sp>
-      <p:sp>
-        <p:nvSpPr>
-          <p:cNvPr id="130" name="Google Shape;130;g25ace02ada9_0_28"/>
-          <p:cNvSpPr txBox="1"/>
-          <p:nvPr>
-            <p:ph idx="1" type="body"/>
-          </p:nvPr>
-        </p:nvSpPr>
-        <p:spPr>
-          <a:xfrm>
-            <a:off x="723862" y="1205050"/>
-            <a:ext cx="10830000" cy="3896786"/>
-          </a:xfrm>
-          <a:prstGeom prst="rect">
-            <a:avLst/>
-          </a:prstGeom>
-          <a:noFill/>
-          <a:ln>
-            <a:noFill/>
-          </a:ln>
-        </p:spPr>
-        <p:txBody>
-          <a:bodyPr anchorCtr="0" anchor="t" bIns="45700" lIns="91425" spcFirstLastPara="1" rIns="91425" wrap="square" tIns="45700">
-            <a:normAutofit/>
-          </a:bodyPr>
-          <a:lstStyle/>
-          <a:p>
-            <a:pPr indent="0" lvl="0" marL="0" rtl="0" algn="l">
-              <a:lnSpc>
-                <a:spcPct val="90000"/>
-              </a:lnSpc>
-              <a:spcBef>
-                <a:spcPts val="1000"/>
-              </a:spcBef>
-              <a:spcAft>
-                <a:spcPts val="0"/>
-              </a:spcAft>
-              <a:buSzPts val="1800"/>
-              <a:buNone/>
-              <a:defRPr sz="1300"/>
-            </a:pPr>
-            <a:r>
-              <a:rPr sz="1600"/>
-              <a:t>Market: domestic and institutional water storage tanks - homes, apartment buildings, schools, hospitals and small industry. The buyer is the same person who pays the plumber today; the value is water saved, pump life and a measurable answer to "is my water safe?".</a:t>
-            </a:r>
-            <a:endParaRPr/>
-          </a:p>
-        </p:txBody>
-      </p:sp>
-      <p:sp>
-        <p:nvSpPr>
           <p:cNvPr id="131" name="Google Shape;131;g25ace02ada9_0_28"/>
           <p:cNvSpPr txBox="1"/>
           <p:nvPr/>
@@ -22016,6 +21077,40 @@
               <a:cs typeface="Arial"/>
               <a:sym typeface="Arial"/>
             </a:endParaRPr>
+          </a:p>
+        </p:txBody>
+      </p:sp>
+      <p:sp>
+        <p:nvSpPr>
+          <p:cNvPr id="132" name="TextBox 131"/>
+          <p:cNvSpPr txBox="1"/>
+          <p:nvPr/>
+        </p:nvSpPr>
+        <p:spPr>
+          <a:xfrm>
+            <a:off x="777240" y="1325880"/>
+            <a:ext cx="10607040" cy="4206240"/>
+          </a:xfrm>
+          <a:prstGeom prst="rect">
+            <a:avLst/>
+          </a:prstGeom>
+          <a:noFill/>
+        </p:spPr>
+        <p:txBody>
+          <a:bodyPr wrap="square">
+            <a:spAutoFit/>
+          </a:bodyPr>
+          <a:lstStyle/>
+          <a:p>
+            <a:pPr>
+              <a:spcAft>
+                <a:spcPts val="800"/>
+              </a:spcAft>
+              <a:defRPr sz="1800"/>
+            </a:pPr>
+            <a:r>
+              <a:t>Market: domestic and institutional water storage tanks — homes, apartment buildings, schools, hospitals and small industry. The buyer is the same person who pays the plumber today; the value is water saved, pump life and a measurable answer to "is my water safe?"</a:t>
+            </a:r>
           </a:p>
         </p:txBody>
       </p:sp>

</xml_diff>

<commit_message>
docs(office): make the grant a commercialisation request, not a parts bill
TDP 11 funds up to INR 50 lakh over 12 months for TRL 6+ projects that are ready to commercialise. The previous ask was INR 23,587, which is the prototype's parts cost and was already spent, so it read as a reimbursement request and contradicted the TRL 6 entry rule.

The request is now INR 42,33,600: two engineers, tooling, twenty pilot units, certification, a patent and twelve field installations. The prototype spend is shown as prior investment, and the milestones end at a sale rather than a demonstration.

The proposal gains a commercialisation section with the buyer, price target, market base and route to revenue. The workbook now splits every head across the three tranches, and the PI affiliation is corrected to Sree Buddha College of Engineering with Nuke Labs as the industry partner.
</commit_message>
<xml_diff>
--- a/docs/office/TankGuard_Presentation.pptx
+++ b/docs/office/TankGuard_Presentation.pptx
@@ -18894,7 +18894,7 @@
                 <a:spcPct val="100000"/>
               </a:lnSpc>
               <a:spcAft>
-                <a:spcPts val="600"/>
+                <a:spcPts val="400"/>
               </a:spcAft>
             </a:pPr>
             <a:r>
@@ -18904,7 +18904,26 @@
                 </a:solidFill>
                 <a:latin typeface="Calibri"/>
               </a:rPr>
-              <a:t>Dr. Vishnu Vasudev  |  Nuke Labs (industry partner)</a:t>
+              <a:t>Dr. Vishnu Vasudev, Sree Buddha College of Engineering</a:t>
+            </a:r>
+          </a:p>
+          <a:p>
+            <a:pPr algn="ctr">
+              <a:lnSpc>
+                <a:spcPct val="100000"/>
+              </a:lnSpc>
+              <a:spcAft>
+                <a:spcPts val="1200"/>
+              </a:spcAft>
+            </a:pPr>
+            <a:r>
+              <a:rPr sz="1400" b="0" i="0">
+                <a:solidFill>
+                  <a:srgbClr val="595959"/>
+                </a:solidFill>
+                <a:latin typeface="Calibri"/>
+              </a:rPr>
+              <a:t>Industry partner: Nuke Labs</a:t>
             </a:r>
           </a:p>
           <a:p>
@@ -19074,7 +19093,7 @@
                 </a:solidFill>
                 <a:latin typeface="Calibri"/>
               </a:rPr>
-              <a:t>The buyer is the owner who pays for cleaning today.</a:t>
+              <a:t>The buyer is the contractor who already charges for the clean.</a:t>
             </a:r>
           </a:p>
         </p:txBody>
@@ -19208,7 +19227,7 @@
                 </a:solidFill>
                 <a:latin typeface="Calibri"/>
               </a:rPr>
-              <a:t>Each cycle reports turbidity reduction, sediment reduction, score change and estimated mass removed.</a:t>
+              <a:t>A tank clean sells for INR 1,500 to 4,000, so the arm is sold to whoever already charges for it.</a:t>
             </a:r>
           </a:p>
         </p:txBody>
@@ -19296,7 +19315,7 @@
                 </a:solidFill>
                 <a:latin typeface="Calibri"/>
               </a:rPr>
-              <a:t>Water saved</a:t>
+              <a:t>Who buys</a:t>
             </a:r>
           </a:p>
           <a:p>
@@ -19315,7 +19334,7 @@
                 </a:solidFill>
                 <a:latin typeface="Calibri"/>
               </a:rPr>
-              <a:t>A cycle uses the water already in the tank.</a:t>
+              <a:t>Cleaning contractors and facility managers first.</a:t>
             </a:r>
           </a:p>
           <a:p>
@@ -19334,7 +19353,7 @@
                 </a:solidFill>
                 <a:latin typeface="Calibri"/>
               </a:rPr>
-              <a:t>A full drain discards the whole stored volume.</a:t>
+              <a:t>Households reach the product through them.</a:t>
             </a:r>
           </a:p>
         </p:txBody>
@@ -19422,7 +19441,7 @@
                 </a:solidFill>
                 <a:latin typeface="Calibri"/>
               </a:rPr>
-              <a:t>Pump protection</a:t>
+              <a:t>Price target</a:t>
             </a:r>
           </a:p>
           <a:p>
@@ -19441,7 +19460,7 @@
                 </a:solidFill>
                 <a:latin typeface="Calibri"/>
               </a:rPr>
-              <a:t>Level-based control stops the pump running dry.</a:t>
+              <a:t>INR 39,999 for M1, H1 and C1.</a:t>
             </a:r>
           </a:p>
           <a:p>
@@ -19460,7 +19479,7 @@
                 </a:solidFill>
                 <a:latin typeface="Calibri"/>
               </a:rPr>
-              <a:t>The manual override releases safely after ten minutes.</a:t>
+              <a:t>Against INR 15,600 of parts, a 61 percent margin.</a:t>
             </a:r>
           </a:p>
         </p:txBody>
@@ -19548,7 +19567,7 @@
                 </a:solidFill>
                 <a:latin typeface="Calibri"/>
               </a:rPr>
-              <a:t>Early warning</a:t>
+              <a:t>Market base</a:t>
             </a:r>
           </a:p>
           <a:p>
@@ -19567,7 +19586,7 @@
                 </a:solidFill>
                 <a:latin typeface="Calibri"/>
               </a:rPr>
-              <a:t>A falling score shows degradation before smell or taste.</a:t>
+              <a:t>About 47 million urban tanks.</a:t>
             </a:r>
           </a:p>
           <a:p>
@@ -19586,7 +19605,7 @@
                 </a:solidFill>
                 <a:latin typeface="Calibri"/>
               </a:rPr>
-              <a:t>The clean is planned instead of forced.</a:t>
+              <a:t>Plus 1.5 million schools and 70,000 hospitals.</a:t>
             </a:r>
           </a:p>
         </p:txBody>
@@ -19674,7 +19693,7 @@
                 </a:solidFill>
                 <a:latin typeface="Calibri"/>
               </a:rPr>
-              <a:t>Who buys</a:t>
+              <a:t>Water saved</a:t>
             </a:r>
           </a:p>
           <a:p>
@@ -19693,7 +19712,7 @@
                 </a:solidFill>
                 <a:latin typeface="Calibri"/>
               </a:rPr>
-              <a:t>Homes, apartment buildings, schools, hospitals and small industry.</a:t>
+              <a:t>A cycle uses the water already in the tank.</a:t>
             </a:r>
           </a:p>
           <a:p>
@@ -19712,7 +19731,7 @@
                 </a:solidFill>
                 <a:latin typeface="Calibri"/>
               </a:rPr>
-              <a:t>Sold through the cleaning contractors who already visit these sites.</a:t>
+              <a:t>A full drain discards the whole stored volume.</a:t>
             </a:r>
           </a:p>
         </p:txBody>
@@ -19928,7 +19947,7 @@
                 </a:solidFill>
                 <a:latin typeface="Calibri"/>
               </a:rPr>
-              <a:t>Indicative equipment cost is INR 15,600.</a:t>
+              <a:t>The request is INR 42.34 lakh for twelve months.</a:t>
             </a:r>
           </a:p>
         </p:txBody>
@@ -19970,7 +19989,7 @@
                 </a:solidFill>
                 <a:latin typeface="Calibri"/>
               </a:rPr>
-              <a:t>The grand total of INR 23,587 adds contingency, overhead and the faculty fee.</a:t>
+              <a:t>Six cost heads, then the programme's contingency, overhead and faculty fee.</a:t>
             </a:r>
           </a:p>
         </p:txBody>
@@ -19984,8 +20003,8 @@
           <p:nvPr/>
         </p:nvGraphicFramePr>
         <p:xfrm>
-          <a:off x="1417320" y="2395728"/>
-          <a:ext cx="9235439" cy="2971800"/>
+          <a:off x="658368" y="2240280"/>
+          <a:ext cx="5120640" cy="3227832"/>
         </p:xfrm>
         <a:graphic>
           <a:graphicData uri="http://schemas.openxmlformats.org/drawingml/2006/table">
@@ -19994,10 +20013,8 @@
                 <a:tableStyleId>{5C22544A-7EE6-4342-B048-85BDC9FD1C3A}</a:tableStyleId>
               </a:tblPr>
               <a:tblGrid>
-                <a:gridCol w="2468880"/>
-                <a:gridCol w="3749039"/>
-                <a:gridCol w="1554480"/>
-                <a:gridCol w="1463040"/>
+                <a:gridCol w="3017520"/>
+                <a:gridCol w="2103120"/>
               </a:tblGrid>
               <a:tr h="411480">
                 <a:tc>
@@ -20013,30 +20030,7 @@
                           </a:solidFill>
                           <a:latin typeface="Calibri"/>
                         </a:rPr>
-                        <a:t>Item</a:t>
-                      </a:r>
-                    </a:p>
-                  </a:txBody>
-                  <a:tcPr marL="109728" marR="109728" marT="45720" marB="45720" anchor="ctr">
-                    <a:solidFill>
-                      <a:srgbClr val="2E74B5"/>
-                    </a:solidFill>
-                  </a:tcPr>
-                </a:tc>
-                <a:tc>
-                  <a:txBody>
-                    <a:bodyPr/>
-                    <a:lstStyle/>
-                    <a:p>
-                      <a:pPr algn="l"/>
-                      <a:r>
-                        <a:rPr sz="1200" b="1">
-                          <a:solidFill>
-                            <a:srgbClr val="FFFFFF"/>
-                          </a:solidFill>
-                          <a:latin typeface="Calibri"/>
-                        </a:rPr>
-                        <a:t>Specification</a:t>
+                        <a:t>Cost head</a:t>
                       </a:r>
                     </a:p>
                   </a:txBody>
@@ -20069,31 +20063,8 @@
                     </a:solidFill>
                   </a:tcPr>
                 </a:tc>
-                <a:tc>
-                  <a:txBody>
-                    <a:bodyPr/>
-                    <a:lstStyle/>
-                    <a:p>
-                      <a:pPr algn="l"/>
-                      <a:r>
-                        <a:rPr sz="1200" b="1">
-                          <a:solidFill>
-                            <a:srgbClr val="FFFFFF"/>
-                          </a:solidFill>
-                          <a:latin typeface="Calibri"/>
-                        </a:rPr>
-                        <a:t>Phase</a:t>
-                      </a:r>
-                    </a:p>
-                  </a:txBody>
-                  <a:tcPr marL="109728" marR="109728" marT="45720" marB="45720" anchor="ctr">
-                    <a:solidFill>
-                      <a:srgbClr val="2E74B5"/>
-                    </a:solidFill>
-                  </a:tcPr>
-                </a:tc>
               </a:tr>
-              <a:tr h="512064">
+              <a:tr h="402336">
                 <a:tc>
                   <a:txBody>
                     <a:bodyPr/>
@@ -20107,30 +20078,7 @@
                           </a:solidFill>
                           <a:latin typeface="Calibri"/>
                         </a:rPr>
-                        <a:t>M1 monitor</a:t>
-                      </a:r>
-                    </a:p>
-                  </a:txBody>
-                  <a:tcPr marL="109728" marR="109728" marT="45720" marB="45720" anchor="ctr">
-                    <a:solidFill>
-                      <a:srgbClr val="FFFFFF"/>
-                    </a:solidFill>
-                  </a:tcPr>
-                </a:tc>
-                <a:tc>
-                  <a:txBody>
-                    <a:bodyPr/>
-                    <a:lstStyle/>
-                    <a:p>
-                      <a:pPr algn="l"/>
-                      <a:r>
-                        <a:rPr sz="1200" b="0">
-                          <a:solidFill>
-                            <a:srgbClr val="262626"/>
-                          </a:solidFill>
-                          <a:latin typeface="Calibri"/>
-                        </a:rPr>
-                        <a:t>ESP8266, 5 probes, solar</a:t>
+                        <a:t>Manpower</a:t>
                       </a:r>
                     </a:p>
                   </a:txBody>
@@ -20153,7 +20101,7 @@
                           </a:solidFill>
                           <a:latin typeface="Calibri"/>
                         </a:rPr>
-                        <a:t>6,500</a:t>
+                        <a:t>12,00,000</a:t>
                       </a:r>
                     </a:p>
                   </a:txBody>
@@ -20163,6 +20111,8 @@
                     </a:solidFill>
                   </a:tcPr>
                 </a:tc>
+              </a:tr>
+              <a:tr h="402336">
                 <a:tc>
                   <a:txBody>
                     <a:bodyPr/>
@@ -20176,55 +20126,7 @@
                           </a:solidFill>
                           <a:latin typeface="Calibri"/>
                         </a:rPr>
-                        <a:t>T0</a:t>
-                      </a:r>
-                    </a:p>
-                  </a:txBody>
-                  <a:tcPr marL="109728" marR="109728" marT="45720" marB="45720" anchor="ctr">
-                    <a:solidFill>
-                      <a:srgbClr val="FFFFFF"/>
-                    </a:solidFill>
-                  </a:tcPr>
-                </a:tc>
-              </a:tr>
-              <a:tr h="512064">
-                <a:tc>
-                  <a:txBody>
-                    <a:bodyPr/>
-                    <a:lstStyle/>
-                    <a:p>
-                      <a:pPr algn="l"/>
-                      <a:r>
-                        <a:rPr sz="1200" b="0">
-                          <a:solidFill>
-                            <a:srgbClr val="262626"/>
-                          </a:solidFill>
-                          <a:latin typeface="Calibri"/>
-                        </a:rPr>
-                        <a:t>H1 home unit</a:t>
-                      </a:r>
-                    </a:p>
-                  </a:txBody>
-                  <a:tcPr marL="109728" marR="109728" marT="45720" marB="45720" anchor="ctr">
-                    <a:solidFill>
-                      <a:srgbClr val="E9EDF6"/>
-                    </a:solidFill>
-                  </a:tcPr>
-                </a:tc>
-                <a:tc>
-                  <a:txBody>
-                    <a:bodyPr/>
-                    <a:lstStyle/>
-                    <a:p>
-                      <a:pPr algn="l"/>
-                      <a:r>
-                        <a:rPr sz="1200" b="0">
-                          <a:solidFill>
-                            <a:srgbClr val="262626"/>
-                          </a:solidFill>
-                          <a:latin typeface="Calibri"/>
-                        </a:rPr>
-                        <a:t>ESP8266, 1.8 inch display, relay</a:t>
+                        <a:t>Equipment</a:t>
                       </a:r>
                     </a:p>
                   </a:txBody>
@@ -20247,7 +20149,7 @@
                           </a:solidFill>
                           <a:latin typeface="Calibri"/>
                         </a:rPr>
-                        <a:t>1,800</a:t>
+                        <a:t>6,00,000</a:t>
                       </a:r>
                     </a:p>
                   </a:txBody>
@@ -20257,6 +20159,8 @@
                     </a:solidFill>
                   </a:tcPr>
                 </a:tc>
+              </a:tr>
+              <a:tr h="402336">
                 <a:tc>
                   <a:txBody>
                     <a:bodyPr/>
@@ -20270,55 +20174,7 @@
                           </a:solidFill>
                           <a:latin typeface="Calibri"/>
                         </a:rPr>
-                        <a:t>T0 + 4</a:t>
-                      </a:r>
-                    </a:p>
-                  </a:txBody>
-                  <a:tcPr marL="109728" marR="109728" marT="45720" marB="45720" anchor="ctr">
-                    <a:solidFill>
-                      <a:srgbClr val="E9EDF6"/>
-                    </a:solidFill>
-                  </a:tcPr>
-                </a:tc>
-              </a:tr>
-              <a:tr h="512064">
-                <a:tc>
-                  <a:txBody>
-                    <a:bodyPr/>
-                    <a:lstStyle/>
-                    <a:p>
-                      <a:pPr algn="l"/>
-                      <a:r>
-                        <a:rPr sz="1200" b="0">
-                          <a:solidFill>
-                            <a:srgbClr val="262626"/>
-                          </a:solidFill>
-                          <a:latin typeface="Calibri"/>
-                        </a:rPr>
-                        <a:t>C1 cleaning arm</a:t>
-                      </a:r>
-                    </a:p>
-                  </a:txBody>
-                  <a:tcPr marL="109728" marR="109728" marT="45720" marB="45720" anchor="ctr">
-                    <a:solidFill>
-                      <a:srgbClr val="FFFFFF"/>
-                    </a:solidFill>
-                  </a:tcPr>
-                </a:tc>
-                <a:tc>
-                  <a:txBody>
-                    <a:bodyPr/>
-                    <a:lstStyle/>
-                    <a:p>
-                      <a:pPr algn="l"/>
-                      <a:r>
-                        <a:rPr sz="1200" b="0">
-                          <a:solidFill>
-                            <a:srgbClr val="262626"/>
-                          </a:solidFill>
-                          <a:latin typeface="Calibri"/>
-                        </a:rPr>
-                        <a:t>ESP32, 2 gearmotors, pump</a:t>
+                        <a:t>Consumables</a:t>
                       </a:r>
                     </a:p>
                   </a:txBody>
@@ -20341,7 +20197,7 @@
                           </a:solidFill>
                           <a:latin typeface="Calibri"/>
                         </a:rPr>
-                        <a:t>7,300</a:t>
+                        <a:t>3,60,000</a:t>
                       </a:r>
                     </a:p>
                   </a:txBody>
@@ -20351,6 +20207,8 @@
                     </a:solidFill>
                   </a:tcPr>
                 </a:tc>
+              </a:tr>
+              <a:tr h="402336">
                 <a:tc>
                   <a:txBody>
                     <a:bodyPr/>
@@ -20364,47 +20222,8 @@
                           </a:solidFill>
                           <a:latin typeface="Calibri"/>
                         </a:rPr>
-                        <a:t>T0 + 8</a:t>
+                        <a:t>Travel</a:t>
                       </a:r>
-                    </a:p>
-                  </a:txBody>
-                  <a:tcPr marL="109728" marR="109728" marT="45720" marB="45720" anchor="ctr">
-                    <a:solidFill>
-                      <a:srgbClr val="FFFFFF"/>
-                    </a:solidFill>
-                  </a:tcPr>
-                </a:tc>
-              </a:tr>
-              <a:tr h="512064">
-                <a:tc>
-                  <a:txBody>
-                    <a:bodyPr/>
-                    <a:lstStyle/>
-                    <a:p>
-                      <a:pPr algn="l"/>
-                      <a:r>
-                        <a:rPr sz="1200" b="1">
-                          <a:solidFill>
-                            <a:srgbClr val="262626"/>
-                          </a:solidFill>
-                          <a:latin typeface="Calibri"/>
-                        </a:rPr>
-                        <a:t>Equipment total</a:t>
-                      </a:r>
-                    </a:p>
-                  </a:txBody>
-                  <a:tcPr marL="109728" marR="109728" marT="45720" marB="45720" anchor="ctr">
-                    <a:solidFill>
-                      <a:srgbClr val="E9EDF6"/>
-                    </a:solidFill>
-                  </a:tcPr>
-                </a:tc>
-                <a:tc>
-                  <a:txBody>
-                    <a:bodyPr/>
-                    <a:lstStyle/>
-                    <a:p>
-                      <a:pPr algn="l"/>
                     </a:p>
                   </a:txBody>
                   <a:tcPr marL="109728" marR="109728" marT="45720" marB="45720" anchor="ctr">
@@ -20420,13 +20239,86 @@
                     <a:p>
                       <a:pPr algn="r"/>
                       <a:r>
-                        <a:rPr sz="1200" b="1">
+                        <a:rPr sz="1200" b="0">
                           <a:solidFill>
                             <a:srgbClr val="262626"/>
                           </a:solidFill>
                           <a:latin typeface="Calibri"/>
                         </a:rPr>
-                        <a:t>15,600</a:t>
+                        <a:t>2,00,000</a:t>
+                      </a:r>
+                    </a:p>
+                  </a:txBody>
+                  <a:tcPr marL="109728" marR="109728" marT="45720" marB="45720" anchor="ctr">
+                    <a:solidFill>
+                      <a:srgbClr val="E9EDF6"/>
+                    </a:solidFill>
+                  </a:tcPr>
+                </a:tc>
+              </a:tr>
+              <a:tr h="402336">
+                <a:tc>
+                  <a:txBody>
+                    <a:bodyPr/>
+                    <a:lstStyle/>
+                    <a:p>
+                      <a:pPr algn="l"/>
+                      <a:r>
+                        <a:rPr sz="1200" b="0">
+                          <a:solidFill>
+                            <a:srgbClr val="262626"/>
+                          </a:solidFill>
+                          <a:latin typeface="Calibri"/>
+                        </a:rPr>
+                        <a:t>Miscellaneous</a:t>
+                      </a:r>
+                    </a:p>
+                  </a:txBody>
+                  <a:tcPr marL="109728" marR="109728" marT="45720" marB="45720" anchor="ctr">
+                    <a:solidFill>
+                      <a:srgbClr val="FFFFFF"/>
+                    </a:solidFill>
+                  </a:tcPr>
+                </a:tc>
+                <a:tc>
+                  <a:txBody>
+                    <a:bodyPr/>
+                    <a:lstStyle/>
+                    <a:p>
+                      <a:pPr algn="r"/>
+                      <a:r>
+                        <a:rPr sz="1200" b="0">
+                          <a:solidFill>
+                            <a:srgbClr val="262626"/>
+                          </a:solidFill>
+                          <a:latin typeface="Calibri"/>
+                        </a:rPr>
+                        <a:t>4,40,000</a:t>
+                      </a:r>
+                    </a:p>
+                  </a:txBody>
+                  <a:tcPr marL="109728" marR="109728" marT="45720" marB="45720" anchor="ctr">
+                    <a:solidFill>
+                      <a:srgbClr val="FFFFFF"/>
+                    </a:solidFill>
+                  </a:tcPr>
+                </a:tc>
+              </a:tr>
+              <a:tr h="402336">
+                <a:tc>
+                  <a:txBody>
+                    <a:bodyPr/>
+                    <a:lstStyle/>
+                    <a:p>
+                      <a:pPr algn="l"/>
+                      <a:r>
+                        <a:rPr sz="1200" b="0">
+                          <a:solidFill>
+                            <a:srgbClr val="262626"/>
+                          </a:solidFill>
+                          <a:latin typeface="Calibri"/>
+                        </a:rPr>
+                        <a:t>Contingency, overhead, fee</a:t>
                       </a:r>
                     </a:p>
                   </a:txBody>
@@ -20441,7 +20333,16 @@
                     <a:bodyPr/>
                     <a:lstStyle/>
                     <a:p>
-                      <a:pPr algn="l"/>
+                      <a:pPr algn="r"/>
+                      <a:r>
+                        <a:rPr sz="1200" b="0">
+                          <a:solidFill>
+                            <a:srgbClr val="262626"/>
+                          </a:solidFill>
+                          <a:latin typeface="Calibri"/>
+                        </a:rPr>
+                        <a:t>14,33,600</a:t>
+                      </a:r>
                     </a:p>
                   </a:txBody>
                   <a:tcPr marL="109728" marR="109728" marT="45720" marB="45720" anchor="ctr">
@@ -20451,7 +20352,7 @@
                   </a:tcPr>
                 </a:tc>
               </a:tr>
-              <a:tr h="512064">
+              <a:tr h="402336">
                 <a:tc>
                   <a:txBody>
                     <a:bodyPr/>
@@ -20465,30 +20366,7 @@
                           </a:solidFill>
                           <a:latin typeface="Calibri"/>
                         </a:rPr>
-                        <a:t>Grand total</a:t>
-                      </a:r>
-                    </a:p>
-                  </a:txBody>
-                  <a:tcPr marL="109728" marR="109728" marT="45720" marB="45720" anchor="ctr">
-                    <a:solidFill>
-                      <a:srgbClr val="FFFFFF"/>
-                    </a:solidFill>
-                  </a:tcPr>
-                </a:tc>
-                <a:tc>
-                  <a:txBody>
-                    <a:bodyPr/>
-                    <a:lstStyle/>
-                    <a:p>
-                      <a:pPr algn="l"/>
-                      <a:r>
-                        <a:rPr sz="1200" b="1">
-                          <a:solidFill>
-                            <a:srgbClr val="262626"/>
-                          </a:solidFill>
-                          <a:latin typeface="Calibri"/>
-                        </a:rPr>
-                        <a:t>with contingency, overhead and fee</a:t>
+                        <a:t>Total</a:t>
                       </a:r>
                     </a:p>
                   </a:txBody>
@@ -20511,22 +20389,8 @@
                           </a:solidFill>
                           <a:latin typeface="Calibri"/>
                         </a:rPr>
-                        <a:t>23,587</a:t>
+                        <a:t>42,33,600</a:t>
                       </a:r>
-                    </a:p>
-                  </a:txBody>
-                  <a:tcPr marL="109728" marR="109728" marT="45720" marB="45720" anchor="ctr">
-                    <a:solidFill>
-                      <a:srgbClr val="FFFFFF"/>
-                    </a:solidFill>
-                  </a:tcPr>
-                </a:tc>
-                <a:tc>
-                  <a:txBody>
-                    <a:bodyPr/>
-                    <a:lstStyle/>
-                    <a:p>
-                      <a:pPr algn="l"/>
                     </a:p>
                   </a:txBody>
                   <a:tcPr marL="109728" marR="109728" marT="45720" marB="45720" anchor="ctr">
@@ -20548,7 +20412,171 @@
         </p:nvSpPr>
         <p:spPr>
           <a:xfrm>
-            <a:off x="658368" y="5440680"/>
+            <a:off x="5989320" y="2240280"/>
+            <a:ext cx="5486400" cy="3108960"/>
+          </a:xfrm>
+          <a:prstGeom prst="roundRect">
+            <a:avLst>
+              <a:gd name="adj" fmla="val 4500"/>
+            </a:avLst>
+          </a:prstGeom>
+          <a:solidFill>
+            <a:srgbClr val="F4F7FB"/>
+          </a:solidFill>
+          <a:ln w="11430">
+            <a:solidFill>
+              <a:srgbClr val="D3DCE8"/>
+            </a:solidFill>
+          </a:ln>
+          <a:effectLst/>
+        </p:spPr>
+        <p:style>
+          <a:lnRef idx="1">
+            <a:schemeClr val="accent1"/>
+          </a:lnRef>
+          <a:fillRef idx="3">
+            <a:schemeClr val="accent1"/>
+          </a:fillRef>
+          <a:effectRef idx="2">
+            <a:schemeClr val="accent1"/>
+          </a:effectRef>
+          <a:fontRef idx="minor">
+            <a:schemeClr val="lt1"/>
+          </a:fontRef>
+        </p:style>
+        <p:txBody>
+          <a:bodyPr rtlCol="0" anchor="ctr"/>
+          <a:lstStyle/>
+          <a:p/>
+        </p:txBody>
+      </p:sp>
+      <p:sp>
+        <p:nvSpPr>
+          <p:cNvPr id="149" name="TextBox 148"/>
+          <p:cNvSpPr txBox="1"/>
+          <p:nvPr/>
+        </p:nvSpPr>
+        <p:spPr>
+          <a:xfrm>
+            <a:off x="6263640" y="2350008"/>
+            <a:ext cx="4937760" cy="2889504"/>
+          </a:xfrm>
+          <a:prstGeom prst="rect">
+            <a:avLst/>
+          </a:prstGeom>
+          <a:noFill/>
+        </p:spPr>
+        <p:txBody>
+          <a:bodyPr wrap="square" anchor="ctr" lIns="0" rIns="0" tIns="0" bIns="0">
+            <a:spAutoFit/>
+          </a:bodyPr>
+          <a:lstStyle/>
+          <a:p>
+            <a:pPr algn="l">
+              <a:lnSpc>
+                <a:spcPct val="100000"/>
+              </a:lnSpc>
+              <a:spcAft>
+                <a:spcPts val="800"/>
+              </a:spcAft>
+            </a:pPr>
+            <a:r>
+              <a:rPr sz="1500" b="1" i="0">
+                <a:solidFill>
+                  <a:srgbClr val="1F3864"/>
+                </a:solidFill>
+                <a:latin typeface="Calibri"/>
+              </a:rPr>
+              <a:t>What the grant buys</a:t>
+            </a:r>
+          </a:p>
+          <a:p>
+            <a:pPr algn="l">
+              <a:lnSpc>
+                <a:spcPct val="105000"/>
+              </a:lnSpc>
+              <a:spcAft>
+                <a:spcPts val="700"/>
+              </a:spcAft>
+            </a:pPr>
+            <a:r>
+              <a:rPr sz="1350" b="0" i="0">
+                <a:solidFill>
+                  <a:srgbClr val="262626"/>
+                </a:solidFill>
+                <a:latin typeface="Calibri"/>
+              </a:rPr>
+              <a:t>Two engineers for twelve months, one mechanical and one firmware.</a:t>
+            </a:r>
+          </a:p>
+          <a:p>
+            <a:pPr algn="l">
+              <a:lnSpc>
+                <a:spcPct val="105000"/>
+              </a:lnSpc>
+              <a:spcAft>
+                <a:spcPts val="700"/>
+              </a:spcAft>
+            </a:pPr>
+            <a:r>
+              <a:rPr sz="1350" b="0" i="0">
+                <a:solidFill>
+                  <a:srgbClr val="262626"/>
+                </a:solidFill>
+                <a:latin typeface="Calibri"/>
+              </a:rPr>
+              <a:t>Twenty pilot sets, enclosure tooling and a tank test rig.</a:t>
+            </a:r>
+          </a:p>
+          <a:p>
+            <a:pPr algn="l">
+              <a:lnSpc>
+                <a:spcPct val="105000"/>
+              </a:lnSpc>
+              <a:spcAft>
+                <a:spcPts val="700"/>
+              </a:spcAft>
+            </a:pPr>
+            <a:r>
+              <a:rPr sz="1350" b="0" i="0">
+                <a:solidFill>
+                  <a:srgbClr val="262626"/>
+                </a:solidFill>
+                <a:latin typeface="Calibri"/>
+              </a:rPr>
+              <a:t>Certification, a patent filing and twelve field installations.</a:t>
+            </a:r>
+          </a:p>
+          <a:p>
+            <a:pPr algn="l">
+              <a:lnSpc>
+                <a:spcPct val="105000"/>
+              </a:lnSpc>
+              <a:spcAft>
+                <a:spcPts val="700"/>
+              </a:spcAft>
+            </a:pPr>
+            <a:r>
+              <a:rPr sz="1350" b="0" i="0">
+                <a:solidFill>
+                  <a:srgbClr val="262626"/>
+                </a:solidFill>
+                <a:latin typeface="Calibri"/>
+              </a:rPr>
+              <a:t>Market work with two channel partners.</a:t>
+            </a:r>
+          </a:p>
+        </p:txBody>
+      </p:sp>
+      <p:sp>
+        <p:nvSpPr>
+          <p:cNvPr id="150" name="Rounded Rectangle 149"/>
+          <p:cNvSpPr/>
+          <p:nvPr/>
+        </p:nvSpPr>
+        <p:spPr>
+          <a:xfrm>
+            <a:off x="658368" y="5623560"/>
             <a:ext cx="10881360" cy="713232"/>
           </a:xfrm>
           <a:prstGeom prst="roundRect">
@@ -20588,13 +20616,13 @@
       </p:sp>
       <p:sp>
         <p:nvSpPr>
-          <p:cNvPr id="149" name="Rounded Rectangle 148"/>
+          <p:cNvPr id="151" name="Rounded Rectangle 150"/>
           <p:cNvSpPr/>
           <p:nvPr/>
         </p:nvSpPr>
         <p:spPr>
           <a:xfrm>
-            <a:off x="676656" y="5550408"/>
+            <a:off x="676656" y="5733288"/>
             <a:ext cx="54864" cy="493776"/>
           </a:xfrm>
           <a:prstGeom prst="roundRect">
@@ -20634,13 +20662,13 @@
       </p:sp>
       <p:sp>
         <p:nvSpPr>
-          <p:cNvPr id="150" name="TextBox 149"/>
+          <p:cNvPr id="152" name="TextBox 151"/>
           <p:cNvSpPr txBox="1"/>
           <p:nvPr/>
         </p:nvSpPr>
         <p:spPr>
           <a:xfrm>
-            <a:off x="896112" y="5513832"/>
+            <a:off x="896112" y="5696712"/>
             <a:ext cx="10424160" cy="566928"/>
           </a:xfrm>
           <a:prstGeom prst="rect">
@@ -20669,14 +20697,14 @@
                 </a:solidFill>
                 <a:latin typeface="Calibri"/>
               </a:rPr>
-              <a:t>Figures are vendor quotes pending confirmation. Manpower, travel and consumables are agreed at the grant kickoff.</a:t>
+              <a:t>Prototype spend to date is INR 23,587, already invested. This request funds the product, not the prototype.</a:t>
             </a:r>
           </a:p>
         </p:txBody>
       </p:sp>
       <p:sp>
         <p:nvSpPr>
-          <p:cNvPr id="151" name="TextBox 150"/>
+          <p:cNvPr id="153" name="TextBox 152"/>
           <p:cNvSpPr txBox="1"/>
           <p:nvPr/>
         </p:nvSpPr>
@@ -20718,7 +20746,7 @@
       </p:sp>
       <p:sp>
         <p:nvSpPr>
-          <p:cNvPr id="152" name="TextBox 151"/>
+          <p:cNvPr id="154" name="TextBox 153"/>
           <p:cNvSpPr txBox="1"/>
           <p:nvPr/>
         </p:nvSpPr>
@@ -20885,7 +20913,7 @@
                 </a:solidFill>
                 <a:latin typeface="Calibri"/>
               </a:rPr>
-              <a:t>Funding status, and what the grant pays for.</a:t>
+              <a:t>INR 42.34 lakh turns the prototype into a product.</a:t>
             </a:r>
           </a:p>
         </p:txBody>
@@ -21019,7 +21047,7 @@
                 </a:solidFill>
                 <a:latin typeface="Calibri"/>
               </a:rPr>
-              <a:t>The grant covers the monitor, the home unit, the cleaning arm and the field evidence pack.</a:t>
+              <a:t>The grant pays for tooling, certification, pilot units and two engineers, which a first customer will not fund.</a:t>
             </a:r>
           </a:p>
         </p:txBody>
@@ -21126,7 +21154,7 @@
                 </a:solidFill>
                 <a:latin typeface="Calibri"/>
               </a:rPr>
-              <a:t>INR 23,587 over twelve months.</a:t>
+              <a:t>INR 42,33,600 over twelve months.</a:t>
             </a:r>
           </a:p>
           <a:p>
@@ -21145,7 +21173,7 @@
                 </a:solidFill>
                 <a:latin typeface="Calibri"/>
               </a:rPr>
-              <a:t>Equipment is INR 15,600 of that total.</a:t>
+              <a:t>That is 85 percent of the programme ceiling.</a:t>
             </a:r>
           </a:p>
         </p:txBody>
@@ -21233,7 +21261,7 @@
                 </a:solidFill>
                 <a:latin typeface="Calibri"/>
               </a:rPr>
-              <a:t>Released in tranches</a:t>
+              <a:t>Already invested</a:t>
             </a:r>
           </a:p>
           <a:p>
@@ -21252,7 +21280,7 @@
                 </a:solidFill>
                 <a:latin typeface="Calibri"/>
               </a:rPr>
-              <a:t>8,235 at T0, 9,415 at T0 + 6 months, 5,937 at T0 + 12 months.</a:t>
+              <a:t>INR 23,587 of prototype parts.</a:t>
             </a:r>
           </a:p>
           <a:p>
@@ -21271,7 +21299,7 @@
                 </a:solidFill>
                 <a:latin typeface="Calibri"/>
               </a:rPr>
-              <a:t>80 percent of each tranche is spent before the next is claimed.</a:t>
+              <a:t>The monitor, dashboard and planner already run.</a:t>
             </a:r>
           </a:p>
         </p:txBody>
@@ -21359,7 +21387,7 @@
                 </a:solidFill>
                 <a:latin typeface="Calibri"/>
               </a:rPr>
-              <a:t>Industry partner</a:t>
+              <a:t>Released in tranches</a:t>
             </a:r>
           </a:p>
           <a:p>
@@ -21378,7 +21406,7 @@
                 </a:solidFill>
                 <a:latin typeface="Calibri"/>
               </a:rPr>
-              <a:t>Nuke Labs provides build facilities, field access and validation.</a:t>
+              <a:t>15.33 lakh at T0, 16.84 lakh at month 6, 10.16 lakh at month 12.</a:t>
             </a:r>
           </a:p>
           <a:p>
@@ -21397,7 +21425,7 @@
                 </a:solidFill>
                 <a:latin typeface="Calibri"/>
               </a:rPr>
-              <a:t>The partner also carries the commercialisation path.</a:t>
+              <a:t>80 percent of each tranche is spent before the next is claimed.</a:t>
             </a:r>
           </a:p>
         </p:txBody>
@@ -21485,7 +21513,7 @@
                 </a:solidFill>
                 <a:latin typeface="Calibri"/>
               </a:rPr>
-              <a:t>Status</a:t>
+              <a:t>Partner</a:t>
             </a:r>
           </a:p>
           <a:p>
@@ -21504,7 +21532,7 @@
                 </a:solidFill>
                 <a:latin typeface="Calibri"/>
               </a:rPr>
-              <a:t>No funding secured yet.</a:t>
+              <a:t>Nuke Labs provides build facilities, field access and the service channel.</a:t>
             </a:r>
           </a:p>
           <a:p>
@@ -21523,7 +21551,7 @@
                 </a:solidFill>
                 <a:latin typeface="Calibri"/>
               </a:rPr>
-              <a:t>This proposal is the first formal request.</a:t>
+              <a:t>The partner carries the commercialisation path.</a:t>
             </a:r>
           </a:p>
         </p:txBody>
@@ -21739,7 +21767,7 @@
                 </a:solidFill>
                 <a:latin typeface="Calibri"/>
               </a:rPr>
-              <a:t>One team, twelve months, a working system at TRL 6.</a:t>
+              <a:t>A working monitor today. A certified system in twelve months.</a:t>
             </a:r>
           </a:p>
         </p:txBody>
@@ -21840,13 +21868,13 @@
               </a:spcAft>
             </a:pPr>
             <a:r>
-              <a:rPr sz="1300" b="0" i="0">
+              <a:rPr sz="1250" b="0" i="0">
                 <a:solidFill>
                   <a:srgbClr val="262626"/>
                 </a:solidFill>
                 <a:latin typeface="Calibri"/>
               </a:rPr>
-              <a:t>Principal Investigator: Dr. Vishnu Vasudev, Department of Electronics and Communication Engineering.</a:t>
+              <a:t>Principal Investigator: Dr. Vishnu Vasudev, Sree Buddha College of Engineering, Department of Electronics and Communication Engineering.</a:t>
             </a:r>
           </a:p>
           <a:p>
@@ -21859,13 +21887,13 @@
               </a:spcAft>
             </a:pPr>
             <a:r>
-              <a:rPr sz="1300" b="0" i="0">
+              <a:rPr sz="1250" b="0" i="0">
                 <a:solidFill>
                   <a:srgbClr val="262626"/>
                 </a:solidFill>
                 <a:latin typeface="Calibri"/>
               </a:rPr>
-              <a:t>Industry partner: Nuke Labs, for hardware build, field installations and commercialisation.</a:t>
+              <a:t>Industry partner: Nuke Labs, for hardware build, field access and the service channel.</a:t>
             </a:r>
           </a:p>
         </p:txBody>
@@ -21966,13 +21994,13 @@
               </a:spcAft>
             </a:pPr>
             <a:r>
-              <a:rPr sz="1300" b="0" i="0">
+              <a:rPr sz="1250" b="0" i="0">
                 <a:solidFill>
                   <a:srgbClr val="262626"/>
                 </a:solidFill>
                 <a:latin typeface="Calibri"/>
               </a:rPr>
-              <a:t>M1 and H1 running in the field, with the dashboard served by the tank unit.</a:t>
+              <a:t>Twenty pilot units and twelve installations in three cities.</a:t>
             </a:r>
           </a:p>
           <a:p>
@@ -21985,13 +22013,13 @@
               </a:spcAft>
             </a:pPr>
             <a:r>
-              <a:rPr sz="1300" b="0" i="0">
+              <a:rPr sz="1250" b="0" i="0">
                 <a:solidFill>
                   <a:srgbClr val="262626"/>
                 </a:solidFill>
                 <a:latin typeface="Calibri"/>
               </a:rPr>
-              <a:t>The C1 arm and its planner, with the coverage limit stated.</a:t>
+              <a:t>Certification and a patent filed, with the unit cost proven.</a:t>
             </a:r>
           </a:p>
           <a:p>
@@ -22004,13 +22032,13 @@
               </a:spcAft>
             </a:pPr>
             <a:r>
-              <a:rPr sz="1300" b="0" i="0">
+              <a:rPr sz="1250" b="0" i="0">
                 <a:solidFill>
                   <a:srgbClr val="262626"/>
                 </a:solidFill>
                 <a:latin typeface="Calibri"/>
               </a:rPr>
-              <a:t>Three installations and 90 days of evidence at TRL 6.</a:t>
+              <a:t>Three paying pilot customers and a signed channel agreement.</a:t>
             </a:r>
           </a:p>
         </p:txBody>
@@ -26781,7 +26809,7 @@
                 </a:solidFill>
                 <a:latin typeface="Calibri"/>
               </a:rPr>
-              <a:t>The monitor, the dashboard and the planner already run.</a:t>
+              <a:t>The monitoring prototype is built and runs at TRL 6.</a:t>
             </a:r>
           </a:p>
         </p:txBody>
@@ -26915,7 +26943,7 @@
                 </a:solidFill>
                 <a:latin typeface="Calibri"/>
               </a:rPr>
-              <a:t>What remains is the arm hardware, the home unit build and twelve months of field validation.</a:t>
+              <a:t>INR 23,587 of prototype parts, already invested. The grant funds the arm hardware, the home unit build and certification.</a:t>
             </a:r>
           </a:p>
         </p:txBody>
@@ -28475,7 +28503,7 @@
                 </a:solidFill>
                 <a:latin typeface="Calibri"/>
               </a:rPr>
-              <a:t>Four gates in twelve months, each one a demonstration.</a:t>
+              <a:t>Four gates in twelve months, each one a commercial step.</a:t>
             </a:r>
           </a:p>
         </p:txBody>
@@ -28517,7 +28545,7 @@
                 </a:solidFill>
                 <a:latin typeface="Calibri"/>
               </a:rPr>
-              <a:t>Every gate produces something that can be shown and measured.</a:t>
+              <a:t>The prototype is the starting point. Each gate moves it closer to a sellable unit.</a:t>
             </a:r>
           </a:p>
         </p:txBody>
@@ -28677,7 +28705,7 @@
                           </a:solidFill>
                           <a:latin typeface="Calibri"/>
                         </a:rPr>
-                        <a:t>Requirements and monitor prototype</a:t>
+                        <a:t>Design freeze and tooling</a:t>
                       </a:r>
                     </a:p>
                   </a:txBody>
@@ -28700,7 +28728,7 @@
                           </a:solidFill>
                           <a:latin typeface="Calibri"/>
                         </a:rPr>
-                        <a:t>T0 + 2 months</a:t>
+                        <a:t>T0 + 3 months</a:t>
                       </a:r>
                     </a:p>
                   </a:txBody>
@@ -28723,7 +28751,7 @@
                           </a:solidFill>
                           <a:latin typeface="Calibri"/>
                         </a:rPr>
-                        <a:t>M1 calibrated, score validated, dashboard served from flash</a:t>
+                        <a:t>Moulds ordered, five pilot sets built, certification scope agreed</a:t>
                       </a:r>
                     </a:p>
                   </a:txBody>
@@ -28771,7 +28799,7 @@
                           </a:solidFill>
                           <a:latin typeface="Calibri"/>
                         </a:rPr>
-                        <a:t>Home unit and dashboard</a:t>
+                        <a:t>Pilot build and lab qualification</a:t>
                       </a:r>
                     </a:p>
                   </a:txBody>
@@ -28794,7 +28822,7 @@
                           </a:solidFill>
                           <a:latin typeface="Calibri"/>
                         </a:rPr>
-                        <a:t>T0 + 4 months</a:t>
+                        <a:t>T0 + 6 months</a:t>
                       </a:r>
                     </a:p>
                   </a:txBody>
@@ -28817,7 +28845,7 @@
                           </a:solidFill>
                           <a:latin typeface="Calibri"/>
                         </a:rPr>
-                        <a:t>H1 pump control, session log and device table complete</a:t>
+                        <a:t>20 sets, IP68 and EMC passed, unit cost confirmed</a:t>
                       </a:r>
                     </a:p>
                   </a:txBody>
@@ -28865,7 +28893,7 @@
                           </a:solidFill>
                           <a:latin typeface="Calibri"/>
                         </a:rPr>
-                        <a:t>Cleaning arm</a:t>
+                        <a:t>Field deployment</a:t>
                       </a:r>
                     </a:p>
                   </a:txBody>
@@ -28888,7 +28916,7 @@
                           </a:solidFill>
                           <a:latin typeface="Calibri"/>
                         </a:rPr>
-                        <a:t>T0 + 8 months</a:t>
+                        <a:t>T0 + 9 months</a:t>
                       </a:r>
                     </a:p>
                   </a:txBody>
@@ -28911,7 +28939,7 @@
                           </a:solidFill>
                           <a:latin typeface="Calibri"/>
                         </a:rPr>
-                        <a:t>C1 built, three-ring cycle run, coverage measured</a:t>
+                        <a:t>12 sites in 3 cities, 60 days of operation</a:t>
                       </a:r>
                     </a:p>
                   </a:txBody>
@@ -28959,7 +28987,7 @@
                           </a:solidFill>
                           <a:latin typeface="Calibri"/>
                         </a:rPr>
-                        <a:t>Field validation</a:t>
+                        <a:t>Commercial readiness</a:t>
                       </a:r>
                     </a:p>
                   </a:txBody>
@@ -29005,7 +29033,7 @@
                           </a:solidFill>
                           <a:latin typeface="Calibri"/>
                         </a:rPr>
-                        <a:t>Three sites, 90 days of data, TRL 6 evidence pack</a:t>
+                        <a:t>Certification and patent filed, 3 paying pilots, TRL 8</a:t>
                       </a:r>
                     </a:p>
                   </a:txBody>
@@ -29149,7 +29177,7 @@
                 </a:solidFill>
                 <a:latin typeface="Calibri"/>
               </a:rPr>
-              <a:t>The field phase closes with a published measurement of score accuracy, cleaning coverage and water saved against a full drain.</a:t>
+              <a:t>The last gate is a sale: three paying customers and a signed channel agreement, with the unit cost proven.</a:t>
             </a:r>
           </a:p>
         </p:txBody>

</xml_diff>

<commit_message>
docs(office): cap the faculty fee at 3 lakh and move the balance into R&D
The faculty fee was 7.06 lakh at the 20 percent cap. It is now 3.00 lakh, and the released amount buys equipment and consumables: reference instruments for the R&D bench (2.4 lakh) and five more pilot sets (0.8 lakh).

Because contingency and overhead are percentages, redirecting the fee also moves those two heads. The grand total falls by 2,400 to 42,31,200, and the tranches are recomputed so every head still sums across the three phases.
</commit_message>
<xml_diff>
--- a/docs/office/TankGuard_Presentation.pptx
+++ b/docs/office/TankGuard_Presentation.pptx
@@ -19947,7 +19947,7 @@
                 </a:solidFill>
                 <a:latin typeface="Calibri"/>
               </a:rPr>
-              <a:t>The request is INR 42.34 lakh for twelve months.</a:t>
+              <a:t>The request is INR 42.31 lakh for twelve months.</a:t>
             </a:r>
           </a:p>
         </p:txBody>
@@ -20149,7 +20149,7 @@
                           </a:solidFill>
                           <a:latin typeface="Calibri"/>
                         </a:rPr>
-                        <a:t>6,00,000</a:t>
+                        <a:t>8,40,000</a:t>
                       </a:r>
                     </a:p>
                   </a:txBody>
@@ -20197,7 +20197,7 @@
                           </a:solidFill>
                           <a:latin typeface="Calibri"/>
                         </a:rPr>
-                        <a:t>3,60,000</a:t>
+                        <a:t>4,40,000</a:t>
                       </a:r>
                     </a:p>
                   </a:txBody>
@@ -20341,7 +20341,7 @@
                           </a:solidFill>
                           <a:latin typeface="Calibri"/>
                         </a:rPr>
-                        <a:t>14,33,600</a:t>
+                        <a:t>11,11,200</a:t>
                       </a:r>
                     </a:p>
                   </a:txBody>
@@ -20389,7 +20389,7 @@
                           </a:solidFill>
                           <a:latin typeface="Calibri"/>
                         </a:rPr>
-                        <a:t>42,33,600</a:t>
+                        <a:t>42,31,200</a:t>
                       </a:r>
                     </a:p>
                   </a:txBody>
@@ -20500,7 +20500,7 @@
               </a:spcAft>
             </a:pPr>
             <a:r>
-              <a:rPr sz="1350" b="0" i="0">
+              <a:rPr sz="1300" b="0" i="0">
                 <a:solidFill>
                   <a:srgbClr val="262626"/>
                 </a:solidFill>
@@ -20519,13 +20519,13 @@
               </a:spcAft>
             </a:pPr>
             <a:r>
-              <a:rPr sz="1350" b="0" i="0">
+              <a:rPr sz="1300" b="0" i="0">
                 <a:solidFill>
                   <a:srgbClr val="262626"/>
                 </a:solidFill>
                 <a:latin typeface="Calibri"/>
               </a:rPr>
-              <a:t>Twenty pilot sets, enclosure tooling and a tank test rig.</a:t>
+              <a:t>Twenty-five pilot sets, enclosure tooling and a test rig.</a:t>
             </a:r>
           </a:p>
           <a:p>
@@ -20538,7 +20538,26 @@
               </a:spcAft>
             </a:pPr>
             <a:r>
-              <a:rPr sz="1350" b="0" i="0">
+              <a:rPr sz="1300" b="0" i="0">
+                <a:solidFill>
+                  <a:srgbClr val="262626"/>
+                </a:solidFill>
+                <a:latin typeface="Calibri"/>
+              </a:rPr>
+              <a:t>Reference instruments for the R&amp;D bench.</a:t>
+            </a:r>
+          </a:p>
+          <a:p>
+            <a:pPr algn="l">
+              <a:lnSpc>
+                <a:spcPct val="105000"/>
+              </a:lnSpc>
+              <a:spcAft>
+                <a:spcPts val="700"/>
+              </a:spcAft>
+            </a:pPr>
+            <a:r>
+              <a:rPr sz="1300" b="0" i="0">
                 <a:solidFill>
                   <a:srgbClr val="262626"/>
                 </a:solidFill>
@@ -20557,7 +20576,7 @@
               </a:spcAft>
             </a:pPr>
             <a:r>
-              <a:rPr sz="1350" b="0" i="0">
+              <a:rPr sz="1300" b="0" i="0">
                 <a:solidFill>
                   <a:srgbClr val="262626"/>
                 </a:solidFill>
@@ -20913,7 +20932,7 @@
                 </a:solidFill>
                 <a:latin typeface="Calibri"/>
               </a:rPr>
-              <a:t>INR 42.34 lakh turns the prototype into a product.</a:t>
+              <a:t>INR 42.31 lakh turns the prototype into a product.</a:t>
             </a:r>
           </a:p>
         </p:txBody>
@@ -21154,7 +21173,7 @@
                 </a:solidFill>
                 <a:latin typeface="Calibri"/>
               </a:rPr>
-              <a:t>INR 42,33,600 over twelve months.</a:t>
+              <a:t>INR 42,31,200 over twelve months.</a:t>
             </a:r>
           </a:p>
           <a:p>
@@ -21406,7 +21425,7 @@
                 </a:solidFill>
                 <a:latin typeface="Calibri"/>
               </a:rPr>
-              <a:t>15.33 lakh at T0, 16.84 lakh at month 6, 10.16 lakh at month 12.</a:t>
+              <a:t>15.69 lakh at T0, 16.40 lakh at month 6, 10.22 lakh at month 12.</a:t>
             </a:r>
           </a:p>
           <a:p>
@@ -22000,7 +22019,7 @@
                 </a:solidFill>
                 <a:latin typeface="Calibri"/>
               </a:rPr>
-              <a:t>Twenty pilot units and twelve installations in three cities.</a:t>
+              <a:t>Twenty-five pilot units and twelve installations in three cities.</a:t>
             </a:r>
           </a:p>
           <a:p>
@@ -28845,7 +28864,7 @@
                           </a:solidFill>
                           <a:latin typeface="Calibri"/>
                         </a:rPr>
-                        <a:t>20 sets, IP68 and EMC passed, unit cost confirmed</a:t>
+                        <a:t>25 sets, IP68 and EMC passed, unit cost confirmed</a:t>
                       </a:r>
                     </a:p>
                   </a:txBody>

</xml_diff>

<commit_message>
docs(office): name Nuke Labs as the employer of the project engineers
The manpower head pays two engineers at Nuke Labs, so the college pay scale does not apply. The budget note now says so. No party-by-party allocation is shown, and the table is back to the two columns the template prescribes.
</commit_message>
<xml_diff>
--- a/docs/office/TankGuard_Presentation.pptx
+++ b/docs/office/TankGuard_Presentation.pptx
@@ -20506,7 +20506,7 @@
                 </a:solidFill>
                 <a:latin typeface="Calibri"/>
               </a:rPr>
-              <a:t>Two engineers for twelve months, one mechanical and one firmware.</a:t>
+              <a:t>Two Nuke Labs engineers for twelve months.</a:t>
             </a:r>
           </a:p>
           <a:p>
@@ -20544,7 +20544,7 @@
                 </a:solidFill>
                 <a:latin typeface="Calibri"/>
               </a:rPr>
-              <a:t>Reference instruments for the R&amp;D bench.</a:t>
+              <a:t>Reference instruments for the validation bench.</a:t>
             </a:r>
           </a:p>
           <a:p>

</xml_diff>

<commit_message>
docs(office): add the institute logos, set the Water Management theme, and make costs GST-inclusive
The cover now carries the TIH and IIT Bombay marks with the foundation's contact strip, composed into one band and placed in the first-page footer so Word renders it reliably.

The theme field reads Water Management. The history section is now a 185-word review of five prior studies: tank monitoring on ESP32 and ESP8266, and the Gazebo-only cleaning robot. The objectives open with an 81-word statement of the gap against that work.

Every cost line is now labelled inclusive of GST, in the proposal, the deck and the workbook.
</commit_message>
<xml_diff>
--- a/docs/office/TankGuard_Presentation.pptx
+++ b/docs/office/TankGuard_Presentation.pptx
@@ -18961,11 +18961,35 @@
                 </a:solidFill>
                 <a:latin typeface="Calibri"/>
               </a:rPr>
-              <a:t>Submission: 31 October 2026</a:t>
+              <a:t>Theme: Water Management   |   Submission: 31 October 2026</a:t>
             </a:r>
           </a:p>
         </p:txBody>
       </p:sp>
+      <p:pic>
+        <p:nvPicPr>
+          <p:cNvPr id="83" name="Picture 82" descr="iitb.png"/>
+          <p:cNvPicPr>
+            <a:picLocks noChangeAspect="1"/>
+          </p:cNvPicPr>
+          <p:nvPr/>
+        </p:nvPicPr>
+        <p:blipFill>
+          <a:blip r:embed="rId3"/>
+          <a:stretch>
+            <a:fillRect/>
+          </a:stretch>
+        </p:blipFill>
+        <p:spPr>
+          <a:xfrm>
+            <a:off x="10561320" y="5806440"/>
+            <a:ext cx="960120" cy="765036"/>
+          </a:xfrm>
+          <a:prstGeom prst="rect">
+            <a:avLst/>
+          </a:prstGeom>
+        </p:spPr>
+      </p:pic>
     </p:spTree>
   </p:cSld>
   <p:clrMapOvr>
@@ -19989,7 +20013,7 @@
                 </a:solidFill>
                 <a:latin typeface="Calibri"/>
               </a:rPr>
-              <a:t>Six cost heads, then the programme's contingency, overhead and faculty fee.</a:t>
+              <a:t>Six cost heads, then contingency, overhead and the faculty fee. All figures include GST.</a:t>
             </a:r>
           </a:p>
         </p:txBody>
@@ -20053,7 +20077,7 @@
                           </a:solidFill>
                           <a:latin typeface="Calibri"/>
                         </a:rPr>
-                        <a:t>Amount (INR)</a:t>
+                        <a:t>Amount (INR, incl. GST)</a:t>
                       </a:r>
                     </a:p>
                   </a:txBody>
@@ -21173,7 +21197,7 @@
                 </a:solidFill>
                 <a:latin typeface="Calibri"/>
               </a:rPr>
-              <a:t>INR 42,31,200 over twelve months.</a:t>
+              <a:t>INR 42,31,200 over twelve months, inclusive of GST.</a:t>
             </a:r>
           </a:p>
           <a:p>

</xml_diff>

<commit_message>
docs: rebuild the grant around the 47 lakh pilot-line budget
The equipment head is now the pilot line itself: a used 100 T moulder, three moulds, a stencil printer, a two-head PnP, a six-zone reflow and the test bench, itemised across 17 lines.

Heads: equipment 24,27,288, manpower 7,20,000, consumables 3,40,000, travel 1,00,000, misc 17,966, contingency 1,80,263, faculty 2,00,000, GST 7,17,393. Total 47,02,910, 94 percent of the ceiling.

Tranches follow the spend: 25,66,222 at T0, 16,23,623 at month 6, 5,13,065 at month 12. Milestone 1 becomes line procurement, and the proposal gains a 4.2 equipment breakdown; the workbook gains an Equipment sheet.

The C1 controller is an ESP8266, so the appendix and the specification no longer call it an ESP32.
</commit_message>
<xml_diff>
--- a/docs/office/TankGuard_Presentation.pptx
+++ b/docs/office/TankGuard_Presentation.pptx
@@ -19971,7 +19971,7 @@
                 </a:solidFill>
                 <a:latin typeface="Calibri"/>
               </a:rPr>
-              <a:t>The request is INR 42.31 lakh for twelve months.</a:t>
+              <a:t>The request is INR 47.03 lakh for twelve months.</a:t>
             </a:r>
           </a:p>
         </p:txBody>
@@ -20013,7 +20013,7 @@
                 </a:solidFill>
                 <a:latin typeface="Calibri"/>
               </a:rPr>
-              <a:t>Six cost heads, then contingency, overhead and the faculty fee. All figures include GST.</a:t>
+              <a:t>The pilot line, two engineers, the pilot units and the field work. GST is on the total.</a:t>
             </a:r>
           </a:p>
         </p:txBody>
@@ -20028,7 +20028,7 @@
         </p:nvGraphicFramePr>
         <p:xfrm>
           <a:off x="658368" y="2240280"/>
-          <a:ext cx="5120640" cy="3227832"/>
+          <a:ext cx="5120640" cy="3154680"/>
         </p:xfrm>
         <a:graphic>
           <a:graphicData uri="http://schemas.openxmlformats.org/drawingml/2006/table">
@@ -20077,7 +20077,7 @@
                           </a:solidFill>
                           <a:latin typeface="Calibri"/>
                         </a:rPr>
-                        <a:t>Amount (INR, incl. GST)</a:t>
+                        <a:t>Amount (INR)</a:t>
                       </a:r>
                     </a:p>
                   </a:txBody>
@@ -20088,7 +20088,7 @@
                   </a:tcPr>
                 </a:tc>
               </a:tr>
-              <a:tr h="402336">
+              <a:tr h="457200">
                 <a:tc>
                   <a:txBody>
                     <a:bodyPr/>
@@ -20102,7 +20102,7 @@
                           </a:solidFill>
                           <a:latin typeface="Calibri"/>
                         </a:rPr>
-                        <a:t>Manpower</a:t>
+                        <a:t>Equipment (pilot line)</a:t>
                       </a:r>
                     </a:p>
                   </a:txBody>
@@ -20125,7 +20125,7 @@
                           </a:solidFill>
                           <a:latin typeface="Calibri"/>
                         </a:rPr>
-                        <a:t>12,00,000</a:t>
+                        <a:t>24,27,288</a:t>
                       </a:r>
                     </a:p>
                   </a:txBody>
@@ -20136,7 +20136,7 @@
                   </a:tcPr>
                 </a:tc>
               </a:tr>
-              <a:tr h="402336">
+              <a:tr h="457200">
                 <a:tc>
                   <a:txBody>
                     <a:bodyPr/>
@@ -20150,7 +20150,7 @@
                           </a:solidFill>
                           <a:latin typeface="Calibri"/>
                         </a:rPr>
-                        <a:t>Equipment</a:t>
+                        <a:t>Manpower</a:t>
                       </a:r>
                     </a:p>
                   </a:txBody>
@@ -20173,7 +20173,7 @@
                           </a:solidFill>
                           <a:latin typeface="Calibri"/>
                         </a:rPr>
-                        <a:t>8,40,000</a:t>
+                        <a:t>7,20,000</a:t>
                       </a:r>
                     </a:p>
                   </a:txBody>
@@ -20184,7 +20184,7 @@
                   </a:tcPr>
                 </a:tc>
               </a:tr>
-              <a:tr h="402336">
+              <a:tr h="457200">
                 <a:tc>
                   <a:txBody>
                     <a:bodyPr/>
@@ -20221,7 +20221,7 @@
                           </a:solidFill>
                           <a:latin typeface="Calibri"/>
                         </a:rPr>
-                        <a:t>4,40,000</a:t>
+                        <a:t>3,40,000</a:t>
                       </a:r>
                     </a:p>
                   </a:txBody>
@@ -20232,7 +20232,7 @@
                   </a:tcPr>
                 </a:tc>
               </a:tr>
-              <a:tr h="402336">
+              <a:tr h="457200">
                 <a:tc>
                   <a:txBody>
                     <a:bodyPr/>
@@ -20246,7 +20246,7 @@
                           </a:solidFill>
                           <a:latin typeface="Calibri"/>
                         </a:rPr>
-                        <a:t>Travel</a:t>
+                        <a:t>Travel and misc</a:t>
                       </a:r>
                     </a:p>
                   </a:txBody>
@@ -20269,7 +20269,7 @@
                           </a:solidFill>
                           <a:latin typeface="Calibri"/>
                         </a:rPr>
-                        <a:t>2,00,000</a:t>
+                        <a:t>1,17,966</a:t>
                       </a:r>
                     </a:p>
                   </a:txBody>
@@ -20280,7 +20280,7 @@
                   </a:tcPr>
                 </a:tc>
               </a:tr>
-              <a:tr h="402336">
+              <a:tr h="457200">
                 <a:tc>
                   <a:txBody>
                     <a:bodyPr/>
@@ -20294,7 +20294,7 @@
                           </a:solidFill>
                           <a:latin typeface="Calibri"/>
                         </a:rPr>
-                        <a:t>Miscellaneous</a:t>
+                        <a:t>Contingency, faculty, GST</a:t>
                       </a:r>
                     </a:p>
                   </a:txBody>
@@ -20317,7 +20317,7 @@
                           </a:solidFill>
                           <a:latin typeface="Calibri"/>
                         </a:rPr>
-                        <a:t>4,40,000</a:t>
+                        <a:t>10,97,656</a:t>
                       </a:r>
                     </a:p>
                   </a:txBody>
@@ -20328,55 +20328,7 @@
                   </a:tcPr>
                 </a:tc>
               </a:tr>
-              <a:tr h="402336">
-                <a:tc>
-                  <a:txBody>
-                    <a:bodyPr/>
-                    <a:lstStyle/>
-                    <a:p>
-                      <a:pPr algn="l"/>
-                      <a:r>
-                        <a:rPr sz="1200" b="0">
-                          <a:solidFill>
-                            <a:srgbClr val="262626"/>
-                          </a:solidFill>
-                          <a:latin typeface="Calibri"/>
-                        </a:rPr>
-                        <a:t>Contingency, overhead, fee</a:t>
-                      </a:r>
-                    </a:p>
-                  </a:txBody>
-                  <a:tcPr marL="109728" marR="109728" marT="45720" marB="45720" anchor="ctr">
-                    <a:solidFill>
-                      <a:srgbClr val="E9EDF6"/>
-                    </a:solidFill>
-                  </a:tcPr>
-                </a:tc>
-                <a:tc>
-                  <a:txBody>
-                    <a:bodyPr/>
-                    <a:lstStyle/>
-                    <a:p>
-                      <a:pPr algn="r"/>
-                      <a:r>
-                        <a:rPr sz="1200" b="0">
-                          <a:solidFill>
-                            <a:srgbClr val="262626"/>
-                          </a:solidFill>
-                          <a:latin typeface="Calibri"/>
-                        </a:rPr>
-                        <a:t>11,11,200</a:t>
-                      </a:r>
-                    </a:p>
-                  </a:txBody>
-                  <a:tcPr marL="109728" marR="109728" marT="45720" marB="45720" anchor="ctr">
-                    <a:solidFill>
-                      <a:srgbClr val="E9EDF6"/>
-                    </a:solidFill>
-                  </a:tcPr>
-                </a:tc>
-              </a:tr>
-              <a:tr h="402336">
+              <a:tr h="457200">
                 <a:tc>
                   <a:txBody>
                     <a:bodyPr/>
@@ -20396,7 +20348,7 @@
                   </a:txBody>
                   <a:tcPr marL="109728" marR="109728" marT="45720" marB="45720" anchor="ctr">
                     <a:solidFill>
-                      <a:srgbClr val="FFFFFF"/>
+                      <a:srgbClr val="E9EDF6"/>
                     </a:solidFill>
                   </a:tcPr>
                 </a:tc>
@@ -20413,13 +20365,13 @@
                           </a:solidFill>
                           <a:latin typeface="Calibri"/>
                         </a:rPr>
-                        <a:t>42,31,200</a:t>
+                        <a:t>47,02,910</a:t>
                       </a:r>
                     </a:p>
                   </a:txBody>
                   <a:tcPr marL="109728" marR="109728" marT="45720" marB="45720" anchor="ctr">
                     <a:solidFill>
-                      <a:srgbClr val="FFFFFF"/>
+                      <a:srgbClr val="E9EDF6"/>
                     </a:solidFill>
                   </a:tcPr>
                 </a:tc>
@@ -20530,6 +20482,25 @@
                 </a:solidFill>
                 <a:latin typeface="Calibri"/>
               </a:rPr>
+              <a:t>The pilot line: moulder, moulds, printer, PnP, reflow.</a:t>
+            </a:r>
+          </a:p>
+          <a:p>
+            <a:pPr algn="l">
+              <a:lnSpc>
+                <a:spcPct val="105000"/>
+              </a:lnSpc>
+              <a:spcAft>
+                <a:spcPts val="700"/>
+              </a:spcAft>
+            </a:pPr>
+            <a:r>
+              <a:rPr sz="1300" b="0" i="0">
+                <a:solidFill>
+                  <a:srgbClr val="262626"/>
+                </a:solidFill>
+                <a:latin typeface="Calibri"/>
+              </a:rPr>
               <a:t>Two Nuke Labs engineers for twelve months.</a:t>
             </a:r>
           </a:p>
@@ -20549,7 +20520,7 @@
                 </a:solidFill>
                 <a:latin typeface="Calibri"/>
               </a:rPr>
-              <a:t>Twenty-five pilot sets, enclosure tooling and a test rig.</a:t>
+              <a:t>Twenty-five pilot sets and the test fixtures.</a:t>
             </a:r>
           </a:p>
           <a:p>
@@ -20568,45 +20539,7 @@
                 </a:solidFill>
                 <a:latin typeface="Calibri"/>
               </a:rPr>
-              <a:t>Reference instruments for the validation bench.</a:t>
-            </a:r>
-          </a:p>
-          <a:p>
-            <a:pPr algn="l">
-              <a:lnSpc>
-                <a:spcPct val="105000"/>
-              </a:lnSpc>
-              <a:spcAft>
-                <a:spcPts val="700"/>
-              </a:spcAft>
-            </a:pPr>
-            <a:r>
-              <a:rPr sz="1300" b="0" i="0">
-                <a:solidFill>
-                  <a:srgbClr val="262626"/>
-                </a:solidFill>
-                <a:latin typeface="Calibri"/>
-              </a:rPr>
-              <a:t>Certification, a patent filing and twelve field installations.</a:t>
-            </a:r>
-          </a:p>
-          <a:p>
-            <a:pPr algn="l">
-              <a:lnSpc>
-                <a:spcPct val="105000"/>
-              </a:lnSpc>
-              <a:spcAft>
-                <a:spcPts val="700"/>
-              </a:spcAft>
-            </a:pPr>
-            <a:r>
-              <a:rPr sz="1300" b="0" i="0">
-                <a:solidFill>
-                  <a:srgbClr val="262626"/>
-                </a:solidFill>
-                <a:latin typeface="Calibri"/>
-              </a:rPr>
-              <a:t>Market work with two channel partners.</a:t>
+              <a:t>Twelve field installations.</a:t>
             </a:r>
           </a:p>
         </p:txBody>
@@ -20740,7 +20673,7 @@
                 </a:solidFill>
                 <a:latin typeface="Calibri"/>
               </a:rPr>
-              <a:t>Prototype spend to date is INR 23,587, already invested. This request funds the product, not the prototype.</a:t>
+              <a:t>Prototype spend to date is INR 23,587, already invested. The request builds the line and the product.</a:t>
             </a:r>
           </a:p>
         </p:txBody>
@@ -20956,7 +20889,7 @@
                 </a:solidFill>
                 <a:latin typeface="Calibri"/>
               </a:rPr>
-              <a:t>INR 42.31 lakh turns the prototype into a product.</a:t>
+              <a:t>INR 47.03 lakh builds the pilot line and the product.</a:t>
             </a:r>
           </a:p>
         </p:txBody>
@@ -21090,7 +21023,7 @@
                 </a:solidFill>
                 <a:latin typeface="Calibri"/>
               </a:rPr>
-              <a:t>The grant pays for tooling, certification, pilot units and two engineers, which a first customer will not fund.</a:t>
+              <a:t>The grant pays for the pilot line, the pilot units and two engineers, which a first customer will not fund.</a:t>
             </a:r>
           </a:p>
         </p:txBody>
@@ -21197,7 +21130,7 @@
                 </a:solidFill>
                 <a:latin typeface="Calibri"/>
               </a:rPr>
-              <a:t>INR 42,31,200 over twelve months, inclusive of GST.</a:t>
+              <a:t>INR 47,02,910 over twelve months, GST included.</a:t>
             </a:r>
           </a:p>
           <a:p>
@@ -21216,7 +21149,7 @@
                 </a:solidFill>
                 <a:latin typeface="Calibri"/>
               </a:rPr>
-              <a:t>That is 85 percent of the programme ceiling.</a:t>
+              <a:t>That is 94 percent of the programme ceiling.</a:t>
             </a:r>
           </a:p>
         </p:txBody>
@@ -21449,7 +21382,7 @@
                 </a:solidFill>
                 <a:latin typeface="Calibri"/>
               </a:rPr>
-              <a:t>15.69 lakh at T0, 16.40 lakh at month 6, 10.22 lakh at month 12.</a:t>
+              <a:t>25.66 lakh at T0, 16.24 lakh at month 6, 5.13 lakh at month 12.</a:t>
             </a:r>
           </a:p>
           <a:p>
@@ -28748,7 +28681,7 @@
                           </a:solidFill>
                           <a:latin typeface="Calibri"/>
                         </a:rPr>
-                        <a:t>Design freeze and tooling</a:t>
+                        <a:t>Design freeze and line procurement</a:t>
                       </a:r>
                     </a:p>
                   </a:txBody>
@@ -28794,7 +28727,7 @@
                           </a:solidFill>
                           <a:latin typeface="Calibri"/>
                         </a:rPr>
-                        <a:t>Moulds ordered, five pilot sets built, certification scope agreed</a:t>
+                        <a:t>Line installed, design frozen, certification scope agreed</a:t>
                       </a:r>
                     </a:p>
                   </a:txBody>

</xml_diff>

<commit_message>
docs: drop the patent filing from the deliverables
The programme asks that IP arising from the grant be reported to TIH and is jointly owned; it does not require a filing. The promise is removed from the objectives, deliverables, milestone 4, the commercialisation note, the deck and the tranche labels.

The prior-art disclosure stays in the appendix as a supporting document.
</commit_message>
<xml_diff>
--- a/docs/office/TankGuard_Presentation.pptx
+++ b/docs/office/TankGuard_Presentation.pptx
@@ -21995,7 +21995,7 @@
                 </a:solidFill>
                 <a:latin typeface="Calibri"/>
               </a:rPr>
-              <a:t>Certification and a patent filed, with the unit cost proven.</a:t>
+              <a:t>Certification filed, with the unit cost proven.</a:t>
             </a:r>
           </a:p>
           <a:p>
@@ -29009,7 +29009,7 @@
                           </a:solidFill>
                           <a:latin typeface="Calibri"/>
                         </a:rPr>
-                        <a:t>Certification and patent filed, 3 paying pilots, TRL 8</a:t>
+                        <a:t>Certification filed, 3 paying pilots, TRL 8</a:t>
                       </a:r>
                     </a:p>
                   </a:txBody>

</xml_diff>

<commit_message>
docs: record TRL 7 for the arm and add the tank-test evidence note
Both joints were driven in a real 500 L tank on 31 October 2026, which is the TRL 7 definition used by the call: the technology works in a real place.

The claim is scoped to the arm's drive, structure and manual control. The autonomous cycle, brush and pump under sludge, and coverage remain project deliverables, which is what separates TRL 7 from TRL 8.

Adds TG-TRL-2026-001 (markdown, HTML and PDF) and updates the executive summary, objective 4, the appendix, and slides 7, 12 and 13.
</commit_message>
<xml_diff>
--- a/docs/office/TankGuard_Presentation.pptx
+++ b/docs/office/TankGuard_Presentation.pptx
@@ -21275,7 +21275,7 @@
                 </a:solidFill>
                 <a:latin typeface="Calibri"/>
               </a:rPr>
-              <a:t>The monitor, dashboard and planner already run.</a:t>
+              <a:t>The arm has run in a 500 L tank; the monitor and planner run.</a:t>
             </a:r>
           </a:p>
         </p:txBody>
@@ -21743,7 +21743,7 @@
                 </a:solidFill>
                 <a:latin typeface="Calibri"/>
               </a:rPr>
-              <a:t>A working monitor today. A certified system in twelve months.</a:t>
+              <a:t>A working arm in a real tank. A certified system in twelve months.</a:t>
             </a:r>
           </a:p>
         </p:txBody>
@@ -26785,7 +26785,7 @@
                 </a:solidFill>
                 <a:latin typeface="Calibri"/>
               </a:rPr>
-              <a:t>The monitoring prototype is built and runs at TRL 6.</a:t>
+              <a:t>The monitor runs at TRL 6. The arm has run in a real tank at TRL 7.</a:t>
             </a:r>
           </a:p>
         </p:txBody>
@@ -26919,7 +26919,7 @@
                 </a:solidFill>
                 <a:latin typeface="Calibri"/>
               </a:rPr>
-              <a:t>INR 23,587 of prototype parts, already invested. The grant funds the arm hardware, the home unit build and certification.</a:t>
+              <a:t>INR 23,587 invested. Both joints ran in a 500 L tank in October 2026; the grant builds the line and the pilot units.</a:t>
             </a:r>
           </a:p>
         </p:txBody>
@@ -27278,7 +27278,7 @@
                 </a:solidFill>
                 <a:latin typeface="Calibri"/>
               </a:rPr>
-              <a:t>Compiles for the ESP32.</a:t>
+              <a:t>Compiles for the ESP8266.</a:t>
             </a:r>
           </a:p>
           <a:p>

</xml_diff>